<commit_message>
Lecture 3 deck: bump body fonts and de-overlap
- Bullets 17 → 19/20pt, pull-quotes 17 → 19/20pt, diagnostic body
  15 → 17pt, tend/escape table 13-14 → 15-16pt with taller rows
  (0.65 → 0.70), creed 30 → 36pt.
- Section-divider title sizes bumped (54 → 58, 'Bob/Bib/B(l)ab/Boobs'
  hero word 90 → 100pt).
- Slide 6 title shortened ('A picture: the phone call ten years out'
  → 'The phone call, ten years out') so it fits on one line.
- Slide 9 bullet container height locked so the pull-quote can't be
  pushed into; slide 14 5th-bullet 'Tend, don't escape.' lifted out
  as a centered closing takeaway.
- Slide 11 title shortened ('Bab is connection. Blab is connection
  drowned out.' → 'Bab vs. blab') for single-line balance.
</commit_message>
<xml_diff>
--- a/assets/the-4b-framework.pptx
+++ b/assets/the-4b-framework.pptx
@@ -2413,7 +2413,7 @@
               <a:buNone/>
             </a:pPr>
             <a:r>
-              <a:rPr lang="en-US" sz="1200" b="1" spc="800" kern="0" dirty="0">
+              <a:rPr lang="en-US" sz="1400" b="1" spc="800" kern="0" dirty="0">
                 <a:solidFill>
                   <a:srgbClr val="D4A93A"/>
                 </a:solidFill>
@@ -2423,7 +2423,7 @@
               </a:rPr>
               <a:t>BOBOLOGY  ·  LECTURE 3</a:t>
             </a:r>
-            <a:endParaRPr lang="en-US" sz="1200" dirty="0"/>
+            <a:endParaRPr lang="en-US" sz="1400" dirty="0"/>
           </a:p>
         </p:txBody>
       </p:sp>
@@ -2452,7 +2452,7 @@
               <a:buNone/>
             </a:pPr>
             <a:r>
-              <a:rPr lang="en-US" sz="2200" dirty="0">
+              <a:rPr lang="en-US" sz="2400" dirty="0">
                 <a:solidFill>
                   <a:srgbClr val="FFD95C"/>
                 </a:solidFill>
@@ -2462,7 +2462,7 @@
               </a:rPr>
               <a:t>·    ✦    ·    ✦    ·    ✦    ·</a:t>
             </a:r>
-            <a:endParaRPr lang="en-US" sz="2200" dirty="0"/>
+            <a:endParaRPr lang="en-US" sz="2400" dirty="0"/>
           </a:p>
         </p:txBody>
       </p:sp>
@@ -2491,7 +2491,7 @@
               <a:buNone/>
             </a:pPr>
             <a:r>
-              <a:rPr lang="en-US" sz="6400" b="1" dirty="0">
+              <a:rPr lang="en-US" sz="6800" b="1" dirty="0">
                 <a:solidFill>
                   <a:srgbClr val="F0E7C8"/>
                 </a:solidFill>
@@ -2501,7 +2501,7 @@
               </a:rPr>
               <a:t>The 4B Framework</a:t>
             </a:r>
-            <a:endParaRPr lang="en-US" sz="6400" dirty="0"/>
+            <a:endParaRPr lang="en-US" sz="6800" dirty="0"/>
           </a:p>
         </p:txBody>
       </p:sp>
@@ -2514,7 +2514,7 @@
         <p:spPr>
           <a:xfrm>
             <a:off x="914400" y="4114800"/>
-            <a:ext cx="10362895" cy="1097280"/>
+            <a:ext cx="10362895" cy="1188720"/>
           </a:xfrm>
           <a:prstGeom prst="rect">
             <a:avLst/>
@@ -2530,7 +2530,7 @@
               <a:buNone/>
             </a:pPr>
             <a:r>
-              <a:rPr lang="en-US" sz="2200" i="1" dirty="0">
+              <a:rPr lang="en-US" sz="2400" i="1" dirty="0">
                 <a:solidFill>
                   <a:srgbClr val="F0E7C8"/>
                 </a:solidFill>
@@ -2540,14 +2540,14 @@
               </a:rPr>
               <a:t>A four-part self-check for when something feels off:</a:t>
             </a:r>
-            <a:endParaRPr lang="en-US" sz="2200" dirty="0"/>
+            <a:endParaRPr lang="en-US" sz="2400" dirty="0"/>
           </a:p>
           <a:p>
             <a:pPr algn="ctr" indent="0" marL="0">
               <a:buNone/>
             </a:pPr>
             <a:r>
-              <a:rPr lang="en-US" sz="2200" i="1" dirty="0">
+              <a:rPr lang="en-US" sz="2400" i="1" dirty="0">
                 <a:solidFill>
                   <a:srgbClr val="F0E7C8"/>
                 </a:solidFill>
@@ -2557,7 +2557,7 @@
               </a:rPr>
               <a:t>Bob  ·  Bib  ·  B(l)ab  ·  Boobs</a:t>
             </a:r>
-            <a:endParaRPr lang="en-US" sz="2200" dirty="0"/>
+            <a:endParaRPr lang="en-US" sz="2400" dirty="0"/>
           </a:p>
         </p:txBody>
       </p:sp>
@@ -2586,7 +2586,7 @@
               <a:buNone/>
             </a:pPr>
             <a:r>
-              <a:rPr lang="en-US" sz="1200" i="1" dirty="0">
+              <a:rPr lang="en-US" sz="1300" i="1" dirty="0">
                 <a:solidFill>
                   <a:srgbClr val="8B8770"/>
                 </a:solidFill>
@@ -2596,7 +2596,7 @@
               </a:rPr>
               <a:t>Derek Wakefield  ·  derekwakefield.com</a:t>
             </a:r>
-            <a:endParaRPr lang="en-US" sz="1200" dirty="0"/>
+            <a:endParaRPr lang="en-US" sz="1300" dirty="0"/>
           </a:p>
         </p:txBody>
       </p:sp>
@@ -2657,7 +2657,7 @@
               <a:buNone/>
             </a:pPr>
             <a:r>
-              <a:rPr lang="en-US" sz="1600" i="1" dirty="0">
+              <a:rPr lang="en-US" sz="1800" i="1" dirty="0">
                 <a:solidFill>
                   <a:srgbClr val="D4A93A"/>
                 </a:solidFill>
@@ -2667,7 +2667,7 @@
               </a:rPr>
               <a:t>§ III</a:t>
             </a:r>
-            <a:endParaRPr lang="en-US" sz="1600" dirty="0"/>
+            <a:endParaRPr lang="en-US" sz="1800" dirty="0"/>
           </a:p>
         </p:txBody>
       </p:sp>
@@ -2679,8 +2679,8 @@
         </p:nvSpPr>
         <p:spPr>
           <a:xfrm>
-            <a:off x="457200" y="2743200"/>
-            <a:ext cx="11277295" cy="1371600"/>
+            <a:off x="457200" y="2468880"/>
+            <a:ext cx="11277295" cy="1645920"/>
           </a:xfrm>
           <a:prstGeom prst="rect">
             <a:avLst/>
@@ -2696,7 +2696,7 @@
               <a:buNone/>
             </a:pPr>
             <a:r>
-              <a:rPr lang="en-US" sz="9000" b="1" dirty="0">
+              <a:rPr lang="en-US" sz="10000" b="1" dirty="0">
                 <a:solidFill>
                   <a:srgbClr val="F0E7C8"/>
                 </a:solidFill>
@@ -2706,7 +2706,7 @@
               </a:rPr>
               <a:t>B(l)ab</a:t>
             </a:r>
-            <a:endParaRPr lang="en-US" sz="9000" dirty="0"/>
+            <a:endParaRPr lang="en-US" sz="10000" dirty="0"/>
           </a:p>
         </p:txBody>
       </p:sp>
@@ -2718,8 +2718,8 @@
         </p:nvSpPr>
         <p:spPr>
           <a:xfrm>
-            <a:off x="914400" y="4389120"/>
-            <a:ext cx="10362895" cy="640080"/>
+            <a:off x="914400" y="4480560"/>
+            <a:ext cx="10362895" cy="731520"/>
           </a:xfrm>
           <a:prstGeom prst="rect">
             <a:avLst/>
@@ -2735,7 +2735,7 @@
               <a:buNone/>
             </a:pPr>
             <a:r>
-              <a:rPr lang="en-US" sz="2000" i="1" dirty="0">
+              <a:rPr lang="en-US" sz="2200" i="1" dirty="0">
                 <a:solidFill>
                   <a:srgbClr val="F0E7C8"/>
                 </a:solidFill>
@@ -2745,7 +2745,7 @@
               </a:rPr>
               <a:t>connection, with the loud parts in parentheses</a:t>
             </a:r>
-            <a:endParaRPr lang="en-US" sz="2000" dirty="0"/>
+            <a:endParaRPr lang="en-US" sz="2200" dirty="0"/>
           </a:p>
         </p:txBody>
       </p:sp>
@@ -2790,7 +2790,7 @@
         <p:spPr>
           <a:xfrm>
             <a:off x="548640" y="457200"/>
-            <a:ext cx="10972800" cy="320040"/>
+            <a:ext cx="10972800" cy="365760"/>
           </a:xfrm>
           <a:prstGeom prst="rect">
             <a:avLst/>
@@ -2806,7 +2806,7 @@
               <a:buNone/>
             </a:pPr>
             <a:r>
-              <a:rPr lang="en-US" sz="1100" b="1" spc="600" kern="0" dirty="0">
+              <a:rPr lang="en-US" sz="1200" b="1" spc="600" kern="0" dirty="0">
                 <a:solidFill>
                   <a:srgbClr val="D4A93A"/>
                 </a:solidFill>
@@ -2816,7 +2816,7 @@
               </a:rPr>
               <a:t>III  ·  B(L)AB</a:t>
             </a:r>
-            <a:endParaRPr lang="en-US" sz="1100" dirty="0"/>
+            <a:endParaRPr lang="en-US" sz="1200" dirty="0"/>
           </a:p>
         </p:txBody>
       </p:sp>
@@ -2828,7 +2828,7 @@
         </p:nvSpPr>
         <p:spPr>
           <a:xfrm>
-            <a:off x="640080" y="868680"/>
+            <a:off x="640080" y="914400"/>
             <a:ext cx="10972800" cy="914400"/>
           </a:xfrm>
           <a:prstGeom prst="rect">
@@ -2845,7 +2845,7 @@
               <a:buNone/>
             </a:pPr>
             <a:r>
-              <a:rPr lang="en-US" sz="3600" b="1" dirty="0">
+              <a:rPr lang="en-US" sz="4000" b="1" dirty="0">
                 <a:solidFill>
                   <a:srgbClr val="0E1238"/>
                 </a:solidFill>
@@ -2853,9 +2853,9 @@
                 <a:ea typeface="Georgia" pitchFamily="34" charset="-122"/>
                 <a:cs typeface="Georgia" pitchFamily="34" charset="-120"/>
               </a:rPr>
-              <a:t>Bab is connection. Blab is connection drowned out.</a:t>
-            </a:r>
-            <a:endParaRPr lang="en-US" sz="3600" dirty="0"/>
+              <a:t>Bab vs. blab</a:t>
+            </a:r>
+            <a:endParaRPr lang="en-US" sz="4000" dirty="0"/>
           </a:p>
         </p:txBody>
       </p:sp>
@@ -2867,8 +2867,8 @@
         </p:nvSpPr>
         <p:spPr>
           <a:xfrm>
-            <a:off x="640080" y="2011680"/>
-            <a:ext cx="10972800" cy="4023360"/>
+            <a:off x="640080" y="2103120"/>
+            <a:ext cx="10972800" cy="4114800"/>
           </a:xfrm>
           <a:prstGeom prst="rect">
             <a:avLst/>
@@ -2891,7 +2891,7 @@
               <a:buChar char="●"/>
             </a:pPr>
             <a:r>
-              <a:rPr lang="en-US" sz="1700" dirty="0">
+              <a:rPr lang="en-US" sz="2000" dirty="0">
                 <a:solidFill>
                   <a:srgbClr val="0E1238"/>
                 </a:solidFill>
@@ -2901,7 +2901,7 @@
               </a:rPr>
               <a:t>Bab is the simple thing — listening, sitting with someone, letting them know they're not alone. Two syllables. The oldest noise.</a:t>
             </a:r>
-            <a:endParaRPr lang="en-US" sz="1700" dirty="0"/>
+            <a:endParaRPr lang="en-US" sz="2000" dirty="0"/>
           </a:p>
           <a:p>
             <a:pPr marL="342900" indent="-342900">
@@ -2915,7 +2915,7 @@
               <a:buChar char="●"/>
             </a:pPr>
             <a:r>
-              <a:rPr lang="en-US" sz="1700" dirty="0">
+              <a:rPr lang="en-US" sz="2000" dirty="0">
                 <a:solidFill>
                   <a:srgbClr val="0E1238"/>
                 </a:solidFill>
@@ -2925,7 +2925,7 @@
               </a:rPr>
               <a:t>Blab is bab with the L unleashed — connection drowned out by your own volume.</a:t>
             </a:r>
-            <a:endParaRPr lang="en-US" sz="1700" dirty="0"/>
+            <a:endParaRPr lang="en-US" sz="2000" dirty="0"/>
           </a:p>
           <a:p>
             <a:pPr marL="342900" indent="-342900">
@@ -2939,7 +2939,7 @@
               <a:buChar char="●"/>
             </a:pPr>
             <a:r>
-              <a:rPr lang="en-US" sz="1700" dirty="0">
+              <a:rPr lang="en-US" sz="2000" dirty="0">
                 <a:solidFill>
                   <a:srgbClr val="0E1238"/>
                 </a:solidFill>
@@ -2949,7 +2949,7 @@
               </a:rPr>
               <a:t>The L stands for the loud stuff: your loves, your losses, the words you can't unsay once they're out.</a:t>
             </a:r>
-            <a:endParaRPr lang="en-US" sz="1700" dirty="0"/>
+            <a:endParaRPr lang="en-US" sz="2000" dirty="0"/>
           </a:p>
           <a:p>
             <a:pPr marL="342900" indent="-342900">
@@ -2963,7 +2963,7 @@
               <a:buChar char="●"/>
             </a:pPr>
             <a:r>
-              <a:rPr lang="en-US" sz="1700" dirty="0">
+              <a:rPr lang="en-US" sz="2000" dirty="0">
                 <a:solidFill>
                   <a:srgbClr val="0E1238"/>
                 </a:solidFill>
@@ -2973,7 +2973,7 @@
               </a:rPr>
               <a:t>You don't delete the L. The L is you. You put it in parentheses — present-but-governed. Silent when the moment asks. Released when the moment asks.</a:t>
             </a:r>
-            <a:endParaRPr lang="en-US" sz="1700" dirty="0"/>
+            <a:endParaRPr lang="en-US" sz="2000" dirty="0"/>
           </a:p>
         </p:txBody>
       </p:sp>
@@ -3002,7 +3002,7 @@
               <a:buNone/>
             </a:pPr>
             <a:r>
-              <a:rPr lang="en-US" sz="1000" i="1" dirty="0">
+              <a:rPr lang="en-US" sz="1100" i="1" dirty="0">
                 <a:solidFill>
                   <a:srgbClr val="8B8770"/>
                 </a:solidFill>
@@ -3012,7 +3012,7 @@
               </a:rPr>
               <a:t>Lecture 3  ·  III</a:t>
             </a:r>
-            <a:endParaRPr lang="en-US" sz="1000" dirty="0"/>
+            <a:endParaRPr lang="en-US" sz="1100" dirty="0"/>
           </a:p>
         </p:txBody>
       </p:sp>
@@ -3057,7 +3057,7 @@
         <p:spPr>
           <a:xfrm>
             <a:off x="548640" y="457200"/>
-            <a:ext cx="10972800" cy="320040"/>
+            <a:ext cx="10972800" cy="365760"/>
           </a:xfrm>
           <a:prstGeom prst="rect">
             <a:avLst/>
@@ -3073,7 +3073,7 @@
               <a:buNone/>
             </a:pPr>
             <a:r>
-              <a:rPr lang="en-US" sz="1100" b="1" spc="600" kern="0" dirty="0">
+              <a:rPr lang="en-US" sz="1200" b="1" spc="600" kern="0" dirty="0">
                 <a:solidFill>
                   <a:srgbClr val="D4A93A"/>
                 </a:solidFill>
@@ -3083,7 +3083,7 @@
               </a:rPr>
               <a:t>III  ·  B(L)AB</a:t>
             </a:r>
-            <a:endParaRPr lang="en-US" sz="1100" dirty="0"/>
+            <a:endParaRPr lang="en-US" sz="1200" dirty="0"/>
           </a:p>
         </p:txBody>
       </p:sp>
@@ -3095,7 +3095,7 @@
         </p:nvSpPr>
         <p:spPr>
           <a:xfrm>
-            <a:off x="640080" y="868680"/>
+            <a:off x="640080" y="914400"/>
             <a:ext cx="10972800" cy="914400"/>
           </a:xfrm>
           <a:prstGeom prst="rect">
@@ -3112,7 +3112,7 @@
               <a:buNone/>
             </a:pPr>
             <a:r>
-              <a:rPr lang="en-US" sz="3600" b="1" dirty="0">
+              <a:rPr lang="en-US" sz="4000" b="1" dirty="0">
                 <a:solidFill>
                   <a:srgbClr val="0E1238"/>
                 </a:solidFill>
@@ -3122,7 +3122,7 @@
               </a:rPr>
               <a:t>Same news. Two responses.</a:t>
             </a:r>
-            <a:endParaRPr lang="en-US" sz="3600" dirty="0"/>
+            <a:endParaRPr lang="en-US" sz="4000" dirty="0"/>
           </a:p>
         </p:txBody>
       </p:sp>
@@ -3134,7 +3134,7 @@
         </p:nvSpPr>
         <p:spPr>
           <a:xfrm>
-            <a:off x="640080" y="1920240"/>
+            <a:off x="640080" y="2103120"/>
             <a:ext cx="5303520" cy="365760"/>
           </a:xfrm>
           <a:prstGeom prst="rect">
@@ -3151,7 +3151,7 @@
               <a:buNone/>
             </a:pPr>
             <a:r>
-              <a:rPr lang="en-US" sz="1200" b="1" spc="600" kern="0" dirty="0">
+              <a:rPr lang="en-US" sz="1400" b="1" spc="600" kern="0" dirty="0">
                 <a:solidFill>
                   <a:srgbClr val="D4A93A"/>
                 </a:solidFill>
@@ -3161,7 +3161,7 @@
               </a:rPr>
               <a:t>BAB</a:t>
             </a:r>
-            <a:endParaRPr lang="en-US" sz="1200" dirty="0"/>
+            <a:endParaRPr lang="en-US" sz="1400" dirty="0"/>
           </a:p>
         </p:txBody>
       </p:sp>
@@ -3173,7 +3173,7 @@
         </p:nvSpPr>
         <p:spPr>
           <a:xfrm>
-            <a:off x="640080" y="2377440"/>
+            <a:off x="640080" y="2560320"/>
             <a:ext cx="5303520" cy="457200"/>
           </a:xfrm>
           <a:prstGeom prst="rect">
@@ -3190,7 +3190,7 @@
               <a:buNone/>
             </a:pPr>
             <a:r>
-              <a:rPr lang="en-US" sz="1500" i="1" dirty="0">
+              <a:rPr lang="en-US" sz="1700" i="1" dirty="0">
                 <a:solidFill>
                   <a:srgbClr val="0E1238"/>
                 </a:solidFill>
@@ -3200,7 +3200,7 @@
               </a:rPr>
               <a:t>Your friend's parent just died.</a:t>
             </a:r>
-            <a:endParaRPr lang="en-US" sz="1500" dirty="0"/>
+            <a:endParaRPr lang="en-US" sz="1700" dirty="0"/>
           </a:p>
         </p:txBody>
       </p:sp>
@@ -3212,8 +3212,8 @@
         </p:nvSpPr>
         <p:spPr>
           <a:xfrm>
-            <a:off x="640080" y="2926080"/>
-            <a:ext cx="5303520" cy="2011680"/>
+            <a:off x="640080" y="3154680"/>
+            <a:ext cx="5303520" cy="1828800"/>
           </a:xfrm>
           <a:prstGeom prst="rect">
             <a:avLst/>
@@ -3229,7 +3229,7 @@
               <a:buNone/>
             </a:pPr>
             <a:r>
-              <a:rPr lang="en-US" sz="1500" dirty="0">
+              <a:rPr lang="en-US" sz="1700" dirty="0">
                 <a:solidFill>
                   <a:srgbClr val="0E1238"/>
                 </a:solidFill>
@@ -3239,7 +3239,7 @@
               </a:rPr>
               <a:t>You sit with them. You let the silence be silent. You ask about their parent. You do not fill the room with your own story about loss.</a:t>
             </a:r>
-            <a:endParaRPr lang="en-US" sz="1500" dirty="0"/>
+            <a:endParaRPr lang="en-US" sz="1700" dirty="0"/>
           </a:p>
         </p:txBody>
       </p:sp>
@@ -3251,7 +3251,7 @@
         </p:nvSpPr>
         <p:spPr>
           <a:xfrm>
-            <a:off x="6309360" y="1920240"/>
+            <a:off x="6309360" y="2103120"/>
             <a:ext cx="5303520" cy="365760"/>
           </a:xfrm>
           <a:prstGeom prst="rect">
@@ -3268,7 +3268,7 @@
               <a:buNone/>
             </a:pPr>
             <a:r>
-              <a:rPr lang="en-US" sz="1200" b="1" spc="600" kern="0" dirty="0">
+              <a:rPr lang="en-US" sz="1400" b="1" spc="600" kern="0" dirty="0">
                 <a:solidFill>
                   <a:srgbClr val="8B8770"/>
                 </a:solidFill>
@@ -3278,7 +3278,7 @@
               </a:rPr>
               <a:t>BLAB</a:t>
             </a:r>
-            <a:endParaRPr lang="en-US" sz="1200" dirty="0"/>
+            <a:endParaRPr lang="en-US" sz="1400" dirty="0"/>
           </a:p>
         </p:txBody>
       </p:sp>
@@ -3290,7 +3290,7 @@
         </p:nvSpPr>
         <p:spPr>
           <a:xfrm>
-            <a:off x="6309360" y="2377440"/>
+            <a:off x="6309360" y="2560320"/>
             <a:ext cx="5303520" cy="457200"/>
           </a:xfrm>
           <a:prstGeom prst="rect">
@@ -3307,7 +3307,7 @@
               <a:buNone/>
             </a:pPr>
             <a:r>
-              <a:rPr lang="en-US" sz="1500" i="1" dirty="0">
+              <a:rPr lang="en-US" sz="1700" i="1" dirty="0">
                 <a:solidFill>
                   <a:srgbClr val="0E1238"/>
                 </a:solidFill>
@@ -3317,7 +3317,7 @@
               </a:rPr>
               <a:t>Your friend's parent just died.</a:t>
             </a:r>
-            <a:endParaRPr lang="en-US" sz="1500" dirty="0"/>
+            <a:endParaRPr lang="en-US" sz="1700" dirty="0"/>
           </a:p>
         </p:txBody>
       </p:sp>
@@ -3329,8 +3329,8 @@
         </p:nvSpPr>
         <p:spPr>
           <a:xfrm>
-            <a:off x="6309360" y="2926080"/>
-            <a:ext cx="5303520" cy="2011680"/>
+            <a:off x="6309360" y="3154680"/>
+            <a:ext cx="5303520" cy="1828800"/>
           </a:xfrm>
           <a:prstGeom prst="rect">
             <a:avLst/>
@@ -3346,7 +3346,7 @@
               <a:buNone/>
             </a:pPr>
             <a:r>
-              <a:rPr lang="en-US" sz="1500" dirty="0">
+              <a:rPr lang="en-US" sz="1700" dirty="0">
                 <a:solidFill>
                   <a:srgbClr val="0E1238"/>
                 </a:solidFill>
@@ -3356,7 +3356,7 @@
               </a:rPr>
               <a:t>You bring up your grandfather. The funeral. How hard it was for you. You mean well, but the room is now about you.</a:t>
             </a:r>
-            <a:endParaRPr lang="en-US" sz="1500" dirty="0"/>
+            <a:endParaRPr lang="en-US" sz="1700" dirty="0"/>
           </a:p>
         </p:txBody>
       </p:sp>
@@ -3368,8 +3368,8 @@
         </p:nvSpPr>
         <p:spPr>
           <a:xfrm>
-            <a:off x="1371600" y="5120640"/>
-            <a:ext cx="9418320" cy="914400"/>
+            <a:off x="1371600" y="5349240"/>
+            <a:ext cx="9418320" cy="777240"/>
           </a:xfrm>
           <a:prstGeom prst="rect">
             <a:avLst/>
@@ -3395,7 +3395,7 @@
                 <a:ea typeface="Georgia" pitchFamily="34" charset="-122"/>
                 <a:cs typeface="Georgia" pitchFamily="34" charset="-120"/>
               </a:rPr>
-              <a:t>"Before letting the L out, ask: am I keeping this in because THEY aren't ready, or because I am not?"</a:t>
+              <a:t>"Before letting the L out, ask: am I keeping this in because they aren't ready, or because I am not?"</a:t>
             </a:r>
             <a:endParaRPr lang="en-US" sz="1700" dirty="0"/>
           </a:p>
@@ -3426,7 +3426,7 @@
               <a:buNone/>
             </a:pPr>
             <a:r>
-              <a:rPr lang="en-US" sz="1000" i="1" dirty="0">
+              <a:rPr lang="en-US" sz="1100" i="1" dirty="0">
                 <a:solidFill>
                   <a:srgbClr val="8B8770"/>
                 </a:solidFill>
@@ -3436,7 +3436,7 @@
               </a:rPr>
               <a:t>Lecture 3  ·  III</a:t>
             </a:r>
-            <a:endParaRPr lang="en-US" sz="1000" dirty="0"/>
+            <a:endParaRPr lang="en-US" sz="1100" dirty="0"/>
           </a:p>
         </p:txBody>
       </p:sp>
@@ -3497,7 +3497,7 @@
               <a:buNone/>
             </a:pPr>
             <a:r>
-              <a:rPr lang="en-US" sz="1600" i="1" dirty="0">
+              <a:rPr lang="en-US" sz="1800" i="1" dirty="0">
                 <a:solidFill>
                   <a:srgbClr val="D4A93A"/>
                 </a:solidFill>
@@ -3507,7 +3507,7 @@
               </a:rPr>
               <a:t>§ IV</a:t>
             </a:r>
-            <a:endParaRPr lang="en-US" sz="1600" dirty="0"/>
+            <a:endParaRPr lang="en-US" sz="1800" dirty="0"/>
           </a:p>
         </p:txBody>
       </p:sp>
@@ -3519,8 +3519,8 @@
         </p:nvSpPr>
         <p:spPr>
           <a:xfrm>
-            <a:off x="457200" y="2743200"/>
-            <a:ext cx="11277295" cy="1371600"/>
+            <a:off x="457200" y="2468880"/>
+            <a:ext cx="11277295" cy="1645920"/>
           </a:xfrm>
           <a:prstGeom prst="rect">
             <a:avLst/>
@@ -3536,7 +3536,7 @@
               <a:buNone/>
             </a:pPr>
             <a:r>
-              <a:rPr lang="en-US" sz="9000" b="1" dirty="0">
+              <a:rPr lang="en-US" sz="10000" b="1" dirty="0">
                 <a:solidFill>
                   <a:srgbClr val="F0E7C8"/>
                 </a:solidFill>
@@ -3546,7 +3546,7 @@
               </a:rPr>
               <a:t>Boobs</a:t>
             </a:r>
-            <a:endParaRPr lang="en-US" sz="9000" dirty="0"/>
+            <a:endParaRPr lang="en-US" sz="10000" dirty="0"/>
           </a:p>
         </p:txBody>
       </p:sp>
@@ -3558,8 +3558,8 @@
         </p:nvSpPr>
         <p:spPr>
           <a:xfrm>
-            <a:off x="914400" y="4389120"/>
-            <a:ext cx="10362895" cy="640080"/>
+            <a:off x="914400" y="4480560"/>
+            <a:ext cx="10362895" cy="731520"/>
           </a:xfrm>
           <a:prstGeom prst="rect">
             <a:avLst/>
@@ -3575,7 +3575,7 @@
               <a:buNone/>
             </a:pPr>
             <a:r>
-              <a:rPr lang="en-US" sz="2000" i="1" dirty="0">
+              <a:rPr lang="en-US" sz="2200" i="1" dirty="0">
                 <a:solidFill>
                   <a:srgbClr val="F0E7C8"/>
                 </a:solidFill>
@@ -3585,7 +3585,7 @@
               </a:rPr>
               <a:t>pleasure — not as sin, not as the whole point</a:t>
             </a:r>
-            <a:endParaRPr lang="en-US" sz="2000" dirty="0"/>
+            <a:endParaRPr lang="en-US" sz="2200" dirty="0"/>
           </a:p>
         </p:txBody>
       </p:sp>
@@ -3630,7 +3630,7 @@
         <p:spPr>
           <a:xfrm>
             <a:off x="548640" y="457200"/>
-            <a:ext cx="10972800" cy="320040"/>
+            <a:ext cx="10972800" cy="365760"/>
           </a:xfrm>
           <a:prstGeom prst="rect">
             <a:avLst/>
@@ -3646,7 +3646,7 @@
               <a:buNone/>
             </a:pPr>
             <a:r>
-              <a:rPr lang="en-US" sz="1100" b="1" spc="600" kern="0" dirty="0">
+              <a:rPr lang="en-US" sz="1200" b="1" spc="600" kern="0" dirty="0">
                 <a:solidFill>
                   <a:srgbClr val="D4A93A"/>
                 </a:solidFill>
@@ -3656,7 +3656,7 @@
               </a:rPr>
               <a:t>IV  ·  BOOBS</a:t>
             </a:r>
-            <a:endParaRPr lang="en-US" sz="1100" dirty="0"/>
+            <a:endParaRPr lang="en-US" sz="1200" dirty="0"/>
           </a:p>
         </p:txBody>
       </p:sp>
@@ -3668,7 +3668,7 @@
         </p:nvSpPr>
         <p:spPr>
           <a:xfrm>
-            <a:off x="640080" y="868680"/>
+            <a:off x="640080" y="914400"/>
             <a:ext cx="10972800" cy="914400"/>
           </a:xfrm>
           <a:prstGeom prst="rect">
@@ -3685,7 +3685,7 @@
               <a:buNone/>
             </a:pPr>
             <a:r>
-              <a:rPr lang="en-US" sz="3600" b="1" dirty="0">
+              <a:rPr lang="en-US" sz="4000" b="1" dirty="0">
                 <a:solidFill>
                   <a:srgbClr val="0E1238"/>
                 </a:solidFill>
@@ -3695,7 +3695,7 @@
               </a:rPr>
               <a:t>Pleasure is a tenet, not a sin or a goal</a:t>
             </a:r>
-            <a:endParaRPr lang="en-US" sz="3600" dirty="0"/>
+            <a:endParaRPr lang="en-US" sz="4000" dirty="0"/>
           </a:p>
         </p:txBody>
       </p:sp>
@@ -3707,8 +3707,8 @@
         </p:nvSpPr>
         <p:spPr>
           <a:xfrm>
-            <a:off x="640080" y="2011680"/>
-            <a:ext cx="10972800" cy="4023360"/>
+            <a:off x="640080" y="2103120"/>
+            <a:ext cx="10972800" cy="3657600"/>
           </a:xfrm>
           <a:prstGeom prst="rect">
             <a:avLst/>
@@ -3731,7 +3731,7 @@
               <a:buChar char="●"/>
             </a:pPr>
             <a:r>
-              <a:rPr lang="en-US" sz="1700" dirty="0">
+              <a:rPr lang="en-US" sz="1900" dirty="0">
                 <a:solidFill>
                   <a:srgbClr val="0E1238"/>
                 </a:solidFill>
@@ -3741,7 +3741,7 @@
               </a:rPr>
               <a:t>One old idea: pleasure is something to hide. Indulge only in private. Apologize for enjoying things. This is wrong.</a:t>
             </a:r>
-            <a:endParaRPr lang="en-US" sz="1700" dirty="0"/>
+            <a:endParaRPr lang="en-US" sz="1900" dirty="0"/>
           </a:p>
           <a:p>
             <a:pPr marL="342900" indent="-342900">
@@ -3755,7 +3755,7 @@
               <a:buChar char="●"/>
             </a:pPr>
             <a:r>
-              <a:rPr lang="en-US" sz="1700" dirty="0">
+              <a:rPr lang="en-US" sz="1900" dirty="0">
                 <a:solidFill>
                   <a:srgbClr val="0E1238"/>
                 </a:solidFill>
@@ -3765,7 +3765,7 @@
               </a:rPr>
               <a:t>Another old idea: life is FOR pleasure. Chase it. This is also wrong — chasing it doesn't work, because we adapt to almost any new pleasure and slide back to baseline.</a:t>
             </a:r>
-            <a:endParaRPr lang="en-US" sz="1700" dirty="0"/>
+            <a:endParaRPr lang="en-US" sz="1900" dirty="0"/>
           </a:p>
           <a:p>
             <a:pPr marL="342900" indent="-342900">
@@ -3779,7 +3779,7 @@
               <a:buChar char="●"/>
             </a:pPr>
             <a:r>
-              <a:rPr lang="en-US" sz="1700" dirty="0">
+              <a:rPr lang="en-US" sz="1900" dirty="0">
                 <a:solidFill>
                   <a:srgbClr val="0E1238"/>
                 </a:solidFill>
@@ -3789,7 +3789,7 @@
               </a:rPr>
               <a:t>Boobs holds pleasure equal with the other three. You don't apologize for it. You also don't build your life around it.</a:t>
             </a:r>
-            <a:endParaRPr lang="en-US" sz="1700" dirty="0"/>
+            <a:endParaRPr lang="en-US" sz="1900" dirty="0"/>
           </a:p>
           <a:p>
             <a:pPr marL="342900" indent="-342900">
@@ -3803,7 +3803,7 @@
               <a:buChar char="●"/>
             </a:pPr>
             <a:r>
-              <a:rPr lang="en-US" sz="1700" dirty="0">
+              <a:rPr lang="en-US" sz="1900" dirty="0">
                 <a:solidFill>
                   <a:srgbClr val="0E1238"/>
                 </a:solidFill>
@@ -3813,7 +3813,7 @@
               </a:rPr>
               <a:t>The test: am I doing this because I enjoy it, or because I'm hiding from one of the other three?</a:t>
             </a:r>
-            <a:endParaRPr lang="en-US" sz="1700" dirty="0"/>
+            <a:endParaRPr lang="en-US" sz="1900" dirty="0"/>
           </a:p>
         </p:txBody>
       </p:sp>
@@ -3825,8 +3825,8 @@
         </p:nvSpPr>
         <p:spPr>
           <a:xfrm>
-            <a:off x="1371600" y="5120640"/>
-            <a:ext cx="9418320" cy="914400"/>
+            <a:off x="1371600" y="5486400"/>
+            <a:ext cx="9418320" cy="640080"/>
           </a:xfrm>
           <a:prstGeom prst="rect">
             <a:avLst/>
@@ -3844,7 +3844,7 @@
               <a:buNone/>
             </a:pPr>
             <a:r>
-              <a:rPr lang="en-US" sz="1700" i="1" dirty="0">
+              <a:rPr lang="en-US" sz="2200" i="1" dirty="0">
                 <a:solidFill>
                   <a:srgbClr val="0E1238"/>
                 </a:solidFill>
@@ -3852,9 +3852,9 @@
                 <a:ea typeface="Georgia" pitchFamily="34" charset="-122"/>
                 <a:cs typeface="Georgia" pitchFamily="34" charset="-120"/>
               </a:rPr>
-              <a:t>"Tend, don't escape.  Pleasure is good.  Pleasure as the exit door from the other three is not."</a:t>
-            </a:r>
-            <a:endParaRPr lang="en-US" sz="1700" dirty="0"/>
+              <a:t>"Tend, don't escape."</a:t>
+            </a:r>
+            <a:endParaRPr lang="en-US" sz="2200" dirty="0"/>
           </a:p>
         </p:txBody>
       </p:sp>
@@ -3883,7 +3883,7 @@
               <a:buNone/>
             </a:pPr>
             <a:r>
-              <a:rPr lang="en-US" sz="1000" i="1" dirty="0">
+              <a:rPr lang="en-US" sz="1100" i="1" dirty="0">
                 <a:solidFill>
                   <a:srgbClr val="8B8770"/>
                 </a:solidFill>
@@ -3893,7 +3893,7 @@
               </a:rPr>
               <a:t>Lecture 3  ·  IV</a:t>
             </a:r>
-            <a:endParaRPr lang="en-US" sz="1000" dirty="0"/>
+            <a:endParaRPr lang="en-US" sz="1100" dirty="0"/>
           </a:p>
         </p:txBody>
       </p:sp>
@@ -3938,7 +3938,7 @@
         <p:spPr>
           <a:xfrm>
             <a:off x="548640" y="457200"/>
-            <a:ext cx="10972800" cy="320040"/>
+            <a:ext cx="10972800" cy="365760"/>
           </a:xfrm>
           <a:prstGeom prst="rect">
             <a:avLst/>
@@ -3954,7 +3954,7 @@
               <a:buNone/>
             </a:pPr>
             <a:r>
-              <a:rPr lang="en-US" sz="1100" b="1" spc="600" kern="0" dirty="0">
+              <a:rPr lang="en-US" sz="1200" b="1" spc="600" kern="0" dirty="0">
                 <a:solidFill>
                   <a:srgbClr val="D4A93A"/>
                 </a:solidFill>
@@ -3964,7 +3964,7 @@
               </a:rPr>
               <a:t>IV  ·  BOOBS</a:t>
             </a:r>
-            <a:endParaRPr lang="en-US" sz="1100" dirty="0"/>
+            <a:endParaRPr lang="en-US" sz="1200" dirty="0"/>
           </a:p>
         </p:txBody>
       </p:sp>
@@ -3976,7 +3976,7 @@
         </p:nvSpPr>
         <p:spPr>
           <a:xfrm>
-            <a:off x="640080" y="868680"/>
+            <a:off x="640080" y="914400"/>
             <a:ext cx="10972800" cy="914400"/>
           </a:xfrm>
           <a:prstGeom prst="rect">
@@ -3993,7 +3993,7 @@
               <a:buNone/>
             </a:pPr>
             <a:r>
-              <a:rPr lang="en-US" sz="3600" b="1" dirty="0">
+              <a:rPr lang="en-US" sz="4000" b="1" dirty="0">
                 <a:solidFill>
                   <a:srgbClr val="0E1238"/>
                 </a:solidFill>
@@ -4003,7 +4003,7 @@
               </a:rPr>
               <a:t>Tend vs. escape — what it looks like</a:t>
             </a:r>
-            <a:endParaRPr lang="en-US" sz="3600" dirty="0"/>
+            <a:endParaRPr lang="en-US" sz="4000" dirty="0"/>
           </a:p>
         </p:txBody>
       </p:sp>
@@ -4015,8 +4015,8 @@
         </p:nvSpPr>
         <p:spPr>
           <a:xfrm>
-            <a:off x="640080" y="1874520"/>
-            <a:ext cx="3200400" cy="594360"/>
+            <a:off x="640080" y="1828800"/>
+            <a:ext cx="3474720" cy="640080"/>
           </a:xfrm>
           <a:prstGeom prst="rect">
             <a:avLst/>
@@ -4032,7 +4032,7 @@
               <a:buNone/>
             </a:pPr>
             <a:r>
-              <a:rPr lang="en-US" sz="1400" b="1" dirty="0">
+              <a:rPr lang="en-US" sz="1600" b="1" dirty="0">
                 <a:solidFill>
                   <a:srgbClr val="0E1238"/>
                 </a:solidFill>
@@ -4042,7 +4042,7 @@
               </a:rPr>
               <a:t>Watching three episodes</a:t>
             </a:r>
-            <a:endParaRPr lang="en-US" sz="1400" dirty="0"/>
+            <a:endParaRPr lang="en-US" sz="1600" dirty="0"/>
           </a:p>
         </p:txBody>
       </p:sp>
@@ -4054,8 +4054,8 @@
         </p:nvSpPr>
         <p:spPr>
           <a:xfrm>
-            <a:off x="3931920" y="1874520"/>
-            <a:ext cx="6400800" cy="594360"/>
+            <a:off x="4206240" y="1828800"/>
+            <a:ext cx="6400800" cy="640080"/>
           </a:xfrm>
           <a:prstGeom prst="rect">
             <a:avLst/>
@@ -4071,7 +4071,7 @@
               <a:buNone/>
             </a:pPr>
             <a:r>
-              <a:rPr lang="en-US" sz="1300" i="1" dirty="0">
+              <a:rPr lang="en-US" sz="1500" i="1" dirty="0">
                 <a:solidFill>
                   <a:srgbClr val="0E1238"/>
                 </a:solidFill>
@@ -4081,7 +4081,7 @@
               </a:rPr>
               <a:t>because it's your favorite show on a slow night.</a:t>
             </a:r>
-            <a:endParaRPr lang="en-US" sz="1300" dirty="0"/>
+            <a:endParaRPr lang="en-US" sz="1500" dirty="0"/>
           </a:p>
         </p:txBody>
       </p:sp>
@@ -4093,8 +4093,8 @@
         </p:nvSpPr>
         <p:spPr>
           <a:xfrm>
-            <a:off x="10424160" y="1874520"/>
-            <a:ext cx="1463040" cy="594360"/>
+            <a:off x="10515600" y="1828800"/>
+            <a:ext cx="1463040" cy="640080"/>
           </a:xfrm>
           <a:prstGeom prst="rect">
             <a:avLst/>
@@ -4110,7 +4110,7 @@
               <a:buNone/>
             </a:pPr>
             <a:r>
-              <a:rPr lang="en-US" sz="1100" b="1" spc="400" kern="0" dirty="0">
+              <a:rPr lang="en-US" sz="1300" b="1" spc="400" kern="0" dirty="0">
                 <a:solidFill>
                   <a:srgbClr val="D4A93A"/>
                 </a:solidFill>
@@ -4120,7 +4120,7 @@
               </a:rPr>
               <a:t>TEND</a:t>
             </a:r>
-            <a:endParaRPr lang="en-US" sz="1100" dirty="0"/>
+            <a:endParaRPr lang="en-US" sz="1300" dirty="0"/>
           </a:p>
         </p:txBody>
       </p:sp>
@@ -4133,7 +4133,7 @@
         <p:spPr>
           <a:xfrm>
             <a:off x="640080" y="2468880"/>
-            <a:ext cx="3200400" cy="594360"/>
+            <a:ext cx="3474720" cy="640080"/>
           </a:xfrm>
           <a:prstGeom prst="rect">
             <a:avLst/>
@@ -4149,7 +4149,7 @@
               <a:buNone/>
             </a:pPr>
             <a:r>
-              <a:rPr lang="en-US" sz="1400" b="1" dirty="0">
+              <a:rPr lang="en-US" sz="1600" b="1" dirty="0">
                 <a:solidFill>
                   <a:srgbClr val="0E1238"/>
                 </a:solidFill>
@@ -4159,7 +4159,7 @@
               </a:rPr>
               <a:t>Watching three episodes</a:t>
             </a:r>
-            <a:endParaRPr lang="en-US" sz="1400" dirty="0"/>
+            <a:endParaRPr lang="en-US" sz="1600" dirty="0"/>
           </a:p>
         </p:txBody>
       </p:sp>
@@ -4171,8 +4171,8 @@
         </p:nvSpPr>
         <p:spPr>
           <a:xfrm>
-            <a:off x="3931920" y="2468880"/>
-            <a:ext cx="6400800" cy="594360"/>
+            <a:off x="4206240" y="2468880"/>
+            <a:ext cx="6400800" cy="640080"/>
           </a:xfrm>
           <a:prstGeom prst="rect">
             <a:avLst/>
@@ -4188,7 +4188,7 @@
               <a:buNone/>
             </a:pPr>
             <a:r>
-              <a:rPr lang="en-US" sz="1300" i="1" dirty="0">
+              <a:rPr lang="en-US" sz="1500" i="1" dirty="0">
                 <a:solidFill>
                   <a:srgbClr val="0E1238"/>
                 </a:solidFill>
@@ -4198,7 +4198,7 @@
               </a:rPr>
               <a:t>because you can't face the email you owe your advisor.</a:t>
             </a:r>
-            <a:endParaRPr lang="en-US" sz="1300" dirty="0"/>
+            <a:endParaRPr lang="en-US" sz="1500" dirty="0"/>
           </a:p>
         </p:txBody>
       </p:sp>
@@ -4210,8 +4210,8 @@
         </p:nvSpPr>
         <p:spPr>
           <a:xfrm>
-            <a:off x="10424160" y="2468880"/>
-            <a:ext cx="1463040" cy="594360"/>
+            <a:off x="10515600" y="2468880"/>
+            <a:ext cx="1463040" cy="640080"/>
           </a:xfrm>
           <a:prstGeom prst="rect">
             <a:avLst/>
@@ -4227,7 +4227,7 @@
               <a:buNone/>
             </a:pPr>
             <a:r>
-              <a:rPr lang="en-US" sz="1100" b="1" spc="400" kern="0" dirty="0">
+              <a:rPr lang="en-US" sz="1300" b="1" spc="400" kern="0" dirty="0">
                 <a:solidFill>
                   <a:srgbClr val="8B8770"/>
                 </a:solidFill>
@@ -4237,7 +4237,7 @@
               </a:rPr>
               <a:t>ESCAPE</a:t>
             </a:r>
-            <a:endParaRPr lang="en-US" sz="1100" dirty="0"/>
+            <a:endParaRPr lang="en-US" sz="1300" dirty="0"/>
           </a:p>
         </p:txBody>
       </p:sp>
@@ -4249,8 +4249,8 @@
         </p:nvSpPr>
         <p:spPr>
           <a:xfrm>
-            <a:off x="640080" y="3063240"/>
-            <a:ext cx="3200400" cy="594360"/>
+            <a:off x="640080" y="3108960"/>
+            <a:ext cx="3474720" cy="640080"/>
           </a:xfrm>
           <a:prstGeom prst="rect">
             <a:avLst/>
@@ -4266,7 +4266,7 @@
               <a:buNone/>
             </a:pPr>
             <a:r>
-              <a:rPr lang="en-US" sz="1400" b="1" dirty="0">
+              <a:rPr lang="en-US" sz="1600" b="1" dirty="0">
                 <a:solidFill>
                   <a:srgbClr val="0E1238"/>
                 </a:solidFill>
@@ -4276,7 +4276,7 @@
               </a:rPr>
               <a:t>Eating ice cream</a:t>
             </a:r>
-            <a:endParaRPr lang="en-US" sz="1400" dirty="0"/>
+            <a:endParaRPr lang="en-US" sz="1600" dirty="0"/>
           </a:p>
         </p:txBody>
       </p:sp>
@@ -4288,8 +4288,8 @@
         </p:nvSpPr>
         <p:spPr>
           <a:xfrm>
-            <a:off x="3931920" y="3063240"/>
-            <a:ext cx="6400800" cy="594360"/>
+            <a:off x="4206240" y="3108960"/>
+            <a:ext cx="6400800" cy="640080"/>
           </a:xfrm>
           <a:prstGeom prst="rect">
             <a:avLst/>
@@ -4305,7 +4305,7 @@
               <a:buNone/>
             </a:pPr>
             <a:r>
-              <a:rPr lang="en-US" sz="1300" i="1" dirty="0">
+              <a:rPr lang="en-US" sz="1500" i="1" dirty="0">
                 <a:solidFill>
                   <a:srgbClr val="0E1238"/>
                 </a:solidFill>
@@ -4315,7 +4315,7 @@
               </a:rPr>
               <a:t>because it is summer and ice cream is good.</a:t>
             </a:r>
-            <a:endParaRPr lang="en-US" sz="1300" dirty="0"/>
+            <a:endParaRPr lang="en-US" sz="1500" dirty="0"/>
           </a:p>
         </p:txBody>
       </p:sp>
@@ -4327,8 +4327,8 @@
         </p:nvSpPr>
         <p:spPr>
           <a:xfrm>
-            <a:off x="10424160" y="3063240"/>
-            <a:ext cx="1463040" cy="594360"/>
+            <a:off x="10515600" y="3108960"/>
+            <a:ext cx="1463040" cy="640080"/>
           </a:xfrm>
           <a:prstGeom prst="rect">
             <a:avLst/>
@@ -4344,7 +4344,7 @@
               <a:buNone/>
             </a:pPr>
             <a:r>
-              <a:rPr lang="en-US" sz="1100" b="1" spc="400" kern="0" dirty="0">
+              <a:rPr lang="en-US" sz="1300" b="1" spc="400" kern="0" dirty="0">
                 <a:solidFill>
                   <a:srgbClr val="D4A93A"/>
                 </a:solidFill>
@@ -4354,7 +4354,7 @@
               </a:rPr>
               <a:t>TEND</a:t>
             </a:r>
-            <a:endParaRPr lang="en-US" sz="1100" dirty="0"/>
+            <a:endParaRPr lang="en-US" sz="1300" dirty="0"/>
           </a:p>
         </p:txBody>
       </p:sp>
@@ -4366,8 +4366,8 @@
         </p:nvSpPr>
         <p:spPr>
           <a:xfrm>
-            <a:off x="640080" y="3657600"/>
-            <a:ext cx="3200400" cy="594360"/>
+            <a:off x="640080" y="3749040"/>
+            <a:ext cx="3474720" cy="640080"/>
           </a:xfrm>
           <a:prstGeom prst="rect">
             <a:avLst/>
@@ -4383,7 +4383,7 @@
               <a:buNone/>
             </a:pPr>
             <a:r>
-              <a:rPr lang="en-US" sz="1400" b="1" dirty="0">
+              <a:rPr lang="en-US" sz="1600" b="1" dirty="0">
                 <a:solidFill>
                   <a:srgbClr val="0E1238"/>
                 </a:solidFill>
@@ -4393,7 +4393,7 @@
               </a:rPr>
               <a:t>Eating ice cream</a:t>
             </a:r>
-            <a:endParaRPr lang="en-US" sz="1400" dirty="0"/>
+            <a:endParaRPr lang="en-US" sz="1600" dirty="0"/>
           </a:p>
         </p:txBody>
       </p:sp>
@@ -4405,8 +4405,8 @@
         </p:nvSpPr>
         <p:spPr>
           <a:xfrm>
-            <a:off x="3931920" y="3657600"/>
-            <a:ext cx="6400800" cy="594360"/>
+            <a:off x="4206240" y="3749040"/>
+            <a:ext cx="6400800" cy="640080"/>
           </a:xfrm>
           <a:prstGeom prst="rect">
             <a:avLst/>
@@ -4422,7 +4422,7 @@
               <a:buNone/>
             </a:pPr>
             <a:r>
-              <a:rPr lang="en-US" sz="1300" i="1" dirty="0">
+              <a:rPr lang="en-US" sz="1500" i="1" dirty="0">
                 <a:solidFill>
                   <a:srgbClr val="0E1238"/>
                 </a:solidFill>
@@ -4432,7 +4432,7 @@
               </a:rPr>
               <a:t>because you just got off a hard phone call.</a:t>
             </a:r>
-            <a:endParaRPr lang="en-US" sz="1300" dirty="0"/>
+            <a:endParaRPr lang="en-US" sz="1500" dirty="0"/>
           </a:p>
         </p:txBody>
       </p:sp>
@@ -4444,8 +4444,8 @@
         </p:nvSpPr>
         <p:spPr>
           <a:xfrm>
-            <a:off x="10424160" y="3657600"/>
-            <a:ext cx="1463040" cy="594360"/>
+            <a:off x="10515600" y="3749040"/>
+            <a:ext cx="1463040" cy="640080"/>
           </a:xfrm>
           <a:prstGeom prst="rect">
             <a:avLst/>
@@ -4461,7 +4461,7 @@
               <a:buNone/>
             </a:pPr>
             <a:r>
-              <a:rPr lang="en-US" sz="1100" b="1" spc="400" kern="0" dirty="0">
+              <a:rPr lang="en-US" sz="1300" b="1" spc="400" kern="0" dirty="0">
                 <a:solidFill>
                   <a:srgbClr val="8B8770"/>
                 </a:solidFill>
@@ -4471,7 +4471,7 @@
               </a:rPr>
               <a:t>ESCAPE</a:t>
             </a:r>
-            <a:endParaRPr lang="en-US" sz="1100" dirty="0"/>
+            <a:endParaRPr lang="en-US" sz="1300" dirty="0"/>
           </a:p>
         </p:txBody>
       </p:sp>
@@ -4483,8 +4483,8 @@
         </p:nvSpPr>
         <p:spPr>
           <a:xfrm>
-            <a:off x="640080" y="4251960"/>
-            <a:ext cx="3200400" cy="594360"/>
+            <a:off x="640080" y="4389120"/>
+            <a:ext cx="3474720" cy="640080"/>
           </a:xfrm>
           <a:prstGeom prst="rect">
             <a:avLst/>
@@ -4500,7 +4500,7 @@
               <a:buNone/>
             </a:pPr>
             <a:r>
-              <a:rPr lang="en-US" sz="1400" b="1" dirty="0">
+              <a:rPr lang="en-US" sz="1600" b="1" dirty="0">
                 <a:solidFill>
                   <a:srgbClr val="0E1238"/>
                 </a:solidFill>
@@ -4510,7 +4510,7 @@
               </a:rPr>
               <a:t>Scrolling for an hour</a:t>
             </a:r>
-            <a:endParaRPr lang="en-US" sz="1400" dirty="0"/>
+            <a:endParaRPr lang="en-US" sz="1600" dirty="0"/>
           </a:p>
         </p:txBody>
       </p:sp>
@@ -4522,8 +4522,8 @@
         </p:nvSpPr>
         <p:spPr>
           <a:xfrm>
-            <a:off x="3931920" y="4251960"/>
-            <a:ext cx="6400800" cy="594360"/>
+            <a:off x="4206240" y="4389120"/>
+            <a:ext cx="6400800" cy="640080"/>
           </a:xfrm>
           <a:prstGeom prst="rect">
             <a:avLst/>
@@ -4539,7 +4539,7 @@
               <a:buNone/>
             </a:pPr>
             <a:r>
-              <a:rPr lang="en-US" sz="1300" i="1" dirty="0">
+              <a:rPr lang="en-US" sz="1500" i="1" dirty="0">
                 <a:solidFill>
                   <a:srgbClr val="0E1238"/>
                 </a:solidFill>
@@ -4549,7 +4549,7 @@
               </a:rPr>
               <a:t>because you actually wanted to see what your cousin posted.</a:t>
             </a:r>
-            <a:endParaRPr lang="en-US" sz="1300" dirty="0"/>
+            <a:endParaRPr lang="en-US" sz="1500" dirty="0"/>
           </a:p>
         </p:txBody>
       </p:sp>
@@ -4561,8 +4561,8 @@
         </p:nvSpPr>
         <p:spPr>
           <a:xfrm>
-            <a:off x="10424160" y="4251960"/>
-            <a:ext cx="1463040" cy="594360"/>
+            <a:off x="10515600" y="4389120"/>
+            <a:ext cx="1463040" cy="640080"/>
           </a:xfrm>
           <a:prstGeom prst="rect">
             <a:avLst/>
@@ -4578,7 +4578,7 @@
               <a:buNone/>
             </a:pPr>
             <a:r>
-              <a:rPr lang="en-US" sz="1100" b="1" spc="400" kern="0" dirty="0">
+              <a:rPr lang="en-US" sz="1300" b="1" spc="400" kern="0" dirty="0">
                 <a:solidFill>
                   <a:srgbClr val="D4A93A"/>
                 </a:solidFill>
@@ -4588,7 +4588,7 @@
               </a:rPr>
               <a:t>TEND</a:t>
             </a:r>
-            <a:endParaRPr lang="en-US" sz="1100" dirty="0"/>
+            <a:endParaRPr lang="en-US" sz="1300" dirty="0"/>
           </a:p>
         </p:txBody>
       </p:sp>
@@ -4600,8 +4600,8 @@
         </p:nvSpPr>
         <p:spPr>
           <a:xfrm>
-            <a:off x="640080" y="4846320"/>
-            <a:ext cx="3200400" cy="594360"/>
+            <a:off x="640080" y="5029200"/>
+            <a:ext cx="3474720" cy="640080"/>
           </a:xfrm>
           <a:prstGeom prst="rect">
             <a:avLst/>
@@ -4617,7 +4617,7 @@
               <a:buNone/>
             </a:pPr>
             <a:r>
-              <a:rPr lang="en-US" sz="1400" b="1" dirty="0">
+              <a:rPr lang="en-US" sz="1600" b="1" dirty="0">
                 <a:solidFill>
                   <a:srgbClr val="0E1238"/>
                 </a:solidFill>
@@ -4627,7 +4627,7 @@
               </a:rPr>
               <a:t>Scrolling for an hour</a:t>
             </a:r>
-            <a:endParaRPr lang="en-US" sz="1400" dirty="0"/>
+            <a:endParaRPr lang="en-US" sz="1600" dirty="0"/>
           </a:p>
         </p:txBody>
       </p:sp>
@@ -4639,8 +4639,8 @@
         </p:nvSpPr>
         <p:spPr>
           <a:xfrm>
-            <a:off x="3931920" y="4846320"/>
-            <a:ext cx="6400800" cy="594360"/>
+            <a:off x="4206240" y="5029200"/>
+            <a:ext cx="6400800" cy="640080"/>
           </a:xfrm>
           <a:prstGeom prst="rect">
             <a:avLst/>
@@ -4656,7 +4656,7 @@
               <a:buNone/>
             </a:pPr>
             <a:r>
-              <a:rPr lang="en-US" sz="1300" i="1" dirty="0">
+              <a:rPr lang="en-US" sz="1500" i="1" dirty="0">
                 <a:solidFill>
                   <a:srgbClr val="0E1238"/>
                 </a:solidFill>
@@ -4666,7 +4666,7 @@
               </a:rPr>
               <a:t>because the silence in your apartment is too loud.</a:t>
             </a:r>
-            <a:endParaRPr lang="en-US" sz="1300" dirty="0"/>
+            <a:endParaRPr lang="en-US" sz="1500" dirty="0"/>
           </a:p>
         </p:txBody>
       </p:sp>
@@ -4678,8 +4678,8 @@
         </p:nvSpPr>
         <p:spPr>
           <a:xfrm>
-            <a:off x="10424160" y="4846320"/>
-            <a:ext cx="1463040" cy="594360"/>
+            <a:off x="10515600" y="5029200"/>
+            <a:ext cx="1463040" cy="640080"/>
           </a:xfrm>
           <a:prstGeom prst="rect">
             <a:avLst/>
@@ -4695,7 +4695,7 @@
               <a:buNone/>
             </a:pPr>
             <a:r>
-              <a:rPr lang="en-US" sz="1100" b="1" spc="400" kern="0" dirty="0">
+              <a:rPr lang="en-US" sz="1300" b="1" spc="400" kern="0" dirty="0">
                 <a:solidFill>
                   <a:srgbClr val="8B8770"/>
                 </a:solidFill>
@@ -4705,7 +4705,7 @@
               </a:rPr>
               <a:t>ESCAPE</a:t>
             </a:r>
-            <a:endParaRPr lang="en-US" sz="1100" dirty="0"/>
+            <a:endParaRPr lang="en-US" sz="1300" dirty="0"/>
           </a:p>
         </p:txBody>
       </p:sp>
@@ -4717,8 +4717,8 @@
         </p:nvSpPr>
         <p:spPr>
           <a:xfrm>
-            <a:off x="640080" y="5577840"/>
-            <a:ext cx="10972800" cy="457200"/>
+            <a:off x="640080" y="5852160"/>
+            <a:ext cx="10972800" cy="411480"/>
           </a:xfrm>
           <a:prstGeom prst="rect">
             <a:avLst/>
@@ -4734,7 +4734,7 @@
               <a:buNone/>
             </a:pPr>
             <a:r>
-              <a:rPr lang="en-US" sz="1500" i="1" dirty="0">
+              <a:rPr lang="en-US" sz="1700" i="1" dirty="0">
                 <a:solidFill>
                   <a:srgbClr val="0E1238"/>
                 </a:solidFill>
@@ -4744,7 +4744,7 @@
               </a:rPr>
               <a:t>Same action. The reason underneath tells you which one it is.</a:t>
             </a:r>
-            <a:endParaRPr lang="en-US" sz="1500" dirty="0"/>
+            <a:endParaRPr lang="en-US" sz="1700" dirty="0"/>
           </a:p>
         </p:txBody>
       </p:sp>
@@ -4773,7 +4773,7 @@
               <a:buNone/>
             </a:pPr>
             <a:r>
-              <a:rPr lang="en-US" sz="1000" i="1" dirty="0">
+              <a:rPr lang="en-US" sz="1100" i="1" dirty="0">
                 <a:solidFill>
                   <a:srgbClr val="8B8770"/>
                 </a:solidFill>
@@ -4783,7 +4783,7 @@
               </a:rPr>
               <a:t>Lecture 3  ·  IV</a:t>
             </a:r>
-            <a:endParaRPr lang="en-US" sz="1000" dirty="0"/>
+            <a:endParaRPr lang="en-US" sz="1100" dirty="0"/>
           </a:p>
         </p:txBody>
       </p:sp>
@@ -4844,7 +4844,7 @@
               <a:buNone/>
             </a:pPr>
             <a:r>
-              <a:rPr lang="en-US" sz="1600" i="1" dirty="0">
+              <a:rPr lang="en-US" sz="1800" i="1" dirty="0">
                 <a:solidFill>
                   <a:srgbClr val="D4A93A"/>
                 </a:solidFill>
@@ -4854,7 +4854,7 @@
               </a:rPr>
               <a:t>§ V</a:t>
             </a:r>
-            <a:endParaRPr lang="en-US" sz="1600" dirty="0"/>
+            <a:endParaRPr lang="en-US" sz="1800" dirty="0"/>
           </a:p>
         </p:txBody>
       </p:sp>
@@ -4866,7 +4866,7 @@
         </p:nvSpPr>
         <p:spPr>
           <a:xfrm>
-            <a:off x="457200" y="2743200"/>
+            <a:off x="457200" y="2651760"/>
             <a:ext cx="11277295" cy="1371600"/>
           </a:xfrm>
           <a:prstGeom prst="rect">
@@ -4883,7 +4883,7 @@
               <a:buNone/>
             </a:pPr>
             <a:r>
-              <a:rPr lang="en-US" sz="5400" b="1" dirty="0">
+              <a:rPr lang="en-US" sz="5800" b="1" dirty="0">
                 <a:solidFill>
                   <a:srgbClr val="F0E7C8"/>
                 </a:solidFill>
@@ -4893,7 +4893,7 @@
               </a:rPr>
               <a:t>The Diagnostic</a:t>
             </a:r>
-            <a:endParaRPr lang="en-US" sz="5400" dirty="0"/>
+            <a:endParaRPr lang="en-US" sz="5800" dirty="0"/>
           </a:p>
         </p:txBody>
       </p:sp>
@@ -4906,7 +4906,7 @@
         <p:spPr>
           <a:xfrm>
             <a:off x="914400" y="4206240"/>
-            <a:ext cx="10362895" cy="640080"/>
+            <a:ext cx="10362895" cy="731520"/>
           </a:xfrm>
           <a:prstGeom prst="rect">
             <a:avLst/>
@@ -4922,7 +4922,7 @@
               <a:buNone/>
             </a:pPr>
             <a:r>
-              <a:rPr lang="en-US" sz="2000" i="1" dirty="0">
+              <a:rPr lang="en-US" sz="2200" i="1" dirty="0">
                 <a:solidFill>
                   <a:srgbClr val="F0E7C8"/>
                 </a:solidFill>
@@ -4932,7 +4932,7 @@
               </a:rPr>
               <a:t>When something feels off — ask the four in order.</a:t>
             </a:r>
-            <a:endParaRPr lang="en-US" sz="2000" dirty="0"/>
+            <a:endParaRPr lang="en-US" sz="2200" dirty="0"/>
           </a:p>
         </p:txBody>
       </p:sp>
@@ -4977,7 +4977,7 @@
         <p:spPr>
           <a:xfrm>
             <a:off x="548640" y="457200"/>
-            <a:ext cx="10972800" cy="320040"/>
+            <a:ext cx="10972800" cy="365760"/>
           </a:xfrm>
           <a:prstGeom prst="rect">
             <a:avLst/>
@@ -4993,7 +4993,7 @@
               <a:buNone/>
             </a:pPr>
             <a:r>
-              <a:rPr lang="en-US" sz="1100" b="1" spc="600" kern="0" dirty="0">
+              <a:rPr lang="en-US" sz="1200" b="1" spc="600" kern="0" dirty="0">
                 <a:solidFill>
                   <a:srgbClr val="D4A93A"/>
                 </a:solidFill>
@@ -5003,7 +5003,7 @@
               </a:rPr>
               <a:t>V  ·  THE DIAGNOSTIC</a:t>
             </a:r>
-            <a:endParaRPr lang="en-US" sz="1100" dirty="0"/>
+            <a:endParaRPr lang="en-US" sz="1200" dirty="0"/>
           </a:p>
         </p:txBody>
       </p:sp>
@@ -5015,7 +5015,7 @@
         </p:nvSpPr>
         <p:spPr>
           <a:xfrm>
-            <a:off x="640080" y="868680"/>
+            <a:off x="640080" y="914400"/>
             <a:ext cx="10972800" cy="914400"/>
           </a:xfrm>
           <a:prstGeom prst="rect">
@@ -5032,7 +5032,7 @@
               <a:buNone/>
             </a:pPr>
             <a:r>
-              <a:rPr lang="en-US" sz="3600" b="1" dirty="0">
+              <a:rPr lang="en-US" sz="4000" b="1" dirty="0">
                 <a:solidFill>
                   <a:srgbClr val="0E1238"/>
                 </a:solidFill>
@@ -5042,7 +5042,7 @@
               </a:rPr>
               <a:t>The four questions</a:t>
             </a:r>
-            <a:endParaRPr lang="en-US" sz="3600" dirty="0"/>
+            <a:endParaRPr lang="en-US" sz="4000" dirty="0"/>
           </a:p>
         </p:txBody>
       </p:sp>
@@ -5054,8 +5054,8 @@
         </p:nvSpPr>
         <p:spPr>
           <a:xfrm>
-            <a:off x="640080" y="1920240"/>
-            <a:ext cx="1645920" cy="868680"/>
+            <a:off x="640080" y="2011680"/>
+            <a:ext cx="1737360" cy="960120"/>
           </a:xfrm>
           <a:prstGeom prst="rect">
             <a:avLst/>
@@ -5071,7 +5071,7 @@
               <a:buNone/>
             </a:pPr>
             <a:r>
-              <a:rPr lang="en-US" sz="2200" b="1" dirty="0">
+              <a:rPr lang="en-US" sz="2600" b="1" dirty="0">
                 <a:solidFill>
                   <a:srgbClr val="D4A93A"/>
                 </a:solidFill>
@@ -5081,7 +5081,7 @@
               </a:rPr>
               <a:t>Bob.</a:t>
             </a:r>
-            <a:endParaRPr lang="en-US" sz="2200" dirty="0"/>
+            <a:endParaRPr lang="en-US" sz="2600" dirty="0"/>
           </a:p>
         </p:txBody>
       </p:sp>
@@ -5093,8 +5093,8 @@
         </p:nvSpPr>
         <p:spPr>
           <a:xfrm>
-            <a:off x="2377440" y="1965960"/>
-            <a:ext cx="9144000" cy="868680"/>
+            <a:off x="2468880" y="2084832"/>
+            <a:ext cx="9144000" cy="960120"/>
           </a:xfrm>
           <a:prstGeom prst="rect">
             <a:avLst/>
@@ -5110,7 +5110,7 @@
               <a:buNone/>
             </a:pPr>
             <a:r>
-              <a:rPr lang="en-US" sz="1500" dirty="0">
+              <a:rPr lang="en-US" sz="1700" dirty="0">
                 <a:solidFill>
                   <a:srgbClr val="0E1238"/>
                 </a:solidFill>
@@ -5120,7 +5120,7 @@
               </a:rPr>
               <a:t>Am I still recognizable as me? Has something dropped out that mattered — and is the new shape better, or just newer?</a:t>
             </a:r>
-            <a:endParaRPr lang="en-US" sz="1500" dirty="0"/>
+            <a:endParaRPr lang="en-US" sz="1700" dirty="0"/>
           </a:p>
         </p:txBody>
       </p:sp>
@@ -5132,8 +5132,8 @@
         </p:nvSpPr>
         <p:spPr>
           <a:xfrm>
-            <a:off x="640080" y="2788920"/>
-            <a:ext cx="1645920" cy="868680"/>
+            <a:off x="640080" y="2971800"/>
+            <a:ext cx="1737360" cy="960120"/>
           </a:xfrm>
           <a:prstGeom prst="rect">
             <a:avLst/>
@@ -5149,7 +5149,7 @@
               <a:buNone/>
             </a:pPr>
             <a:r>
-              <a:rPr lang="en-US" sz="2200" b="1" dirty="0">
+              <a:rPr lang="en-US" sz="2600" b="1" dirty="0">
                 <a:solidFill>
                   <a:srgbClr val="D4A93A"/>
                 </a:solidFill>
@@ -5159,7 +5159,7 @@
               </a:rPr>
               <a:t>Bib.</a:t>
             </a:r>
-            <a:endParaRPr lang="en-US" sz="2200" dirty="0"/>
+            <a:endParaRPr lang="en-US" sz="2600" dirty="0"/>
           </a:p>
         </p:txBody>
       </p:sp>
@@ -5171,8 +5171,8 @@
         </p:nvSpPr>
         <p:spPr>
           <a:xfrm>
-            <a:off x="2377440" y="2834640"/>
-            <a:ext cx="9144000" cy="868680"/>
+            <a:off x="2468880" y="3044952"/>
+            <a:ext cx="9144000" cy="960120"/>
           </a:xfrm>
           <a:prstGeom prst="rect">
             <a:avLst/>
@@ -5188,7 +5188,7 @@
               <a:buNone/>
             </a:pPr>
             <a:r>
-              <a:rPr lang="en-US" sz="1500" dirty="0">
+              <a:rPr lang="en-US" sz="1700" dirty="0">
                 <a:solidFill>
                   <a:srgbClr val="0E1238"/>
                 </a:solidFill>
@@ -5198,7 +5198,7 @@
               </a:rPr>
               <a:t>When did I last sleep enough, eat real food, drink water, get outside? Am I getting energy back from my week, or only spending it?</a:t>
             </a:r>
-            <a:endParaRPr lang="en-US" sz="1500" dirty="0"/>
+            <a:endParaRPr lang="en-US" sz="1700" dirty="0"/>
           </a:p>
         </p:txBody>
       </p:sp>
@@ -5210,8 +5210,8 @@
         </p:nvSpPr>
         <p:spPr>
           <a:xfrm>
-            <a:off x="640080" y="3657600"/>
-            <a:ext cx="1645920" cy="868680"/>
+            <a:off x="640080" y="3931920"/>
+            <a:ext cx="1737360" cy="960120"/>
           </a:xfrm>
           <a:prstGeom prst="rect">
             <a:avLst/>
@@ -5227,7 +5227,7 @@
               <a:buNone/>
             </a:pPr>
             <a:r>
-              <a:rPr lang="en-US" sz="2200" b="1" dirty="0">
+              <a:rPr lang="en-US" sz="2600" b="1" dirty="0">
                 <a:solidFill>
                   <a:srgbClr val="D4A93A"/>
                 </a:solidFill>
@@ -5237,7 +5237,7 @@
               </a:rPr>
               <a:t>B(l)ab.</a:t>
             </a:r>
-            <a:endParaRPr lang="en-US" sz="2200" dirty="0"/>
+            <a:endParaRPr lang="en-US" sz="2600" dirty="0"/>
           </a:p>
         </p:txBody>
       </p:sp>
@@ -5249,8 +5249,8 @@
         </p:nvSpPr>
         <p:spPr>
           <a:xfrm>
-            <a:off x="2377440" y="3703320"/>
-            <a:ext cx="9144000" cy="868680"/>
+            <a:off x="2468880" y="4005072"/>
+            <a:ext cx="9144000" cy="960120"/>
           </a:xfrm>
           <a:prstGeom prst="rect">
             <a:avLst/>
@@ -5266,7 +5266,7 @@
               <a:buNone/>
             </a:pPr>
             <a:r>
-              <a:rPr lang="en-US" sz="1500" dirty="0">
+              <a:rPr lang="en-US" sz="1700" dirty="0">
                 <a:solidFill>
                   <a:srgbClr val="0E1238"/>
                 </a:solidFill>
@@ -5276,7 +5276,7 @@
               </a:rPr>
               <a:t>Who am I in real conversation with this week? Have I gone silent everywhere — or loud everywhere? Is the parenthesis honest?</a:t>
             </a:r>
-            <a:endParaRPr lang="en-US" sz="1500" dirty="0"/>
+            <a:endParaRPr lang="en-US" sz="1700" dirty="0"/>
           </a:p>
         </p:txBody>
       </p:sp>
@@ -5288,8 +5288,8 @@
         </p:nvSpPr>
         <p:spPr>
           <a:xfrm>
-            <a:off x="640080" y="4526280"/>
-            <a:ext cx="1645920" cy="868680"/>
+            <a:off x="640080" y="4892040"/>
+            <a:ext cx="1737360" cy="960120"/>
           </a:xfrm>
           <a:prstGeom prst="rect">
             <a:avLst/>
@@ -5305,7 +5305,7 @@
               <a:buNone/>
             </a:pPr>
             <a:r>
-              <a:rPr lang="en-US" sz="2200" b="1" dirty="0">
+              <a:rPr lang="en-US" sz="2600" b="1" dirty="0">
                 <a:solidFill>
                   <a:srgbClr val="D4A93A"/>
                 </a:solidFill>
@@ -5315,7 +5315,7 @@
               </a:rPr>
               <a:t>Boobs.</a:t>
             </a:r>
-            <a:endParaRPr lang="en-US" sz="2200" dirty="0"/>
+            <a:endParaRPr lang="en-US" sz="2600" dirty="0"/>
           </a:p>
         </p:txBody>
       </p:sp>
@@ -5327,8 +5327,8 @@
         </p:nvSpPr>
         <p:spPr>
           <a:xfrm>
-            <a:off x="2377440" y="4572000"/>
-            <a:ext cx="9144000" cy="868680"/>
+            <a:off x="2468880" y="4965192"/>
+            <a:ext cx="9144000" cy="960120"/>
           </a:xfrm>
           <a:prstGeom prst="rect">
             <a:avLst/>
@@ -5344,7 +5344,7 @@
               <a:buNone/>
             </a:pPr>
             <a:r>
-              <a:rPr lang="en-US" sz="1500" dirty="0">
+              <a:rPr lang="en-US" sz="1700" dirty="0">
                 <a:solidFill>
                   <a:srgbClr val="0E1238"/>
                 </a:solidFill>
@@ -5354,7 +5354,7 @@
               </a:rPr>
               <a:t>When did I last enjoy something on purpose — not as an exit from one of the other three?</a:t>
             </a:r>
-            <a:endParaRPr lang="en-US" sz="1500" dirty="0"/>
+            <a:endParaRPr lang="en-US" sz="1700" dirty="0"/>
           </a:p>
         </p:txBody>
       </p:sp>
@@ -5366,8 +5366,8 @@
         </p:nvSpPr>
         <p:spPr>
           <a:xfrm>
-            <a:off x="640080" y="5577840"/>
-            <a:ext cx="10972800" cy="548640"/>
+            <a:off x="640080" y="5897880"/>
+            <a:ext cx="10972800" cy="411480"/>
           </a:xfrm>
           <a:prstGeom prst="rect">
             <a:avLst/>
@@ -5383,7 +5383,7 @@
               <a:buNone/>
             </a:pPr>
             <a:r>
-              <a:rPr lang="en-US" sz="1500" i="1" dirty="0">
+              <a:rPr lang="en-US" sz="1700" i="1" dirty="0">
                 <a:solidFill>
                   <a:srgbClr val="0E1238"/>
                 </a:solidFill>
@@ -5393,7 +5393,7 @@
               </a:rPr>
               <a:t>Each question, asked clean, points back to one thing you can change tomorrow morning.</a:t>
             </a:r>
-            <a:endParaRPr lang="en-US" sz="1500" dirty="0"/>
+            <a:endParaRPr lang="en-US" sz="1700" dirty="0"/>
           </a:p>
         </p:txBody>
       </p:sp>
@@ -5422,7 +5422,7 @@
               <a:buNone/>
             </a:pPr>
             <a:r>
-              <a:rPr lang="en-US" sz="1000" i="1" dirty="0">
+              <a:rPr lang="en-US" sz="1100" i="1" dirty="0">
                 <a:solidFill>
                   <a:srgbClr val="8B8770"/>
                 </a:solidFill>
@@ -5432,7 +5432,7 @@
               </a:rPr>
               <a:t>Lecture 3  ·  V</a:t>
             </a:r>
-            <a:endParaRPr lang="en-US" sz="1000" dirty="0"/>
+            <a:endParaRPr lang="en-US" sz="1100" dirty="0"/>
           </a:p>
         </p:txBody>
       </p:sp>
@@ -5493,7 +5493,7 @@
               <a:buNone/>
             </a:pPr>
             <a:r>
-              <a:rPr lang="en-US" sz="1100" b="1" spc="700" kern="0" dirty="0">
+              <a:rPr lang="en-US" sz="1300" b="1" spc="700" kern="0" dirty="0">
                 <a:solidFill>
                   <a:srgbClr val="D4A93A"/>
                 </a:solidFill>
@@ -5503,7 +5503,7 @@
               </a:rPr>
               <a:t>LECTURE 3  ·  THE CREED</a:t>
             </a:r>
-            <a:endParaRPr lang="en-US" sz="1100" dirty="0"/>
+            <a:endParaRPr lang="en-US" sz="1300" dirty="0"/>
           </a:p>
         </p:txBody>
       </p:sp>
@@ -5515,8 +5515,8 @@
         </p:nvSpPr>
         <p:spPr>
           <a:xfrm>
-            <a:off x="914400" y="1920240"/>
-            <a:ext cx="10362895" cy="3291840"/>
+            <a:off x="914400" y="1645920"/>
+            <a:ext cx="10362895" cy="3657600"/>
           </a:xfrm>
           <a:prstGeom prst="rect">
             <a:avLst/>
@@ -5530,12 +5530,12 @@
           <a:p>
             <a:pPr algn="ctr" indent="0" marL="0">
               <a:lnSpc>
-                <a:spcPct val="150000"/>
+                <a:spcPct val="145000"/>
               </a:lnSpc>
               <a:buNone/>
             </a:pPr>
             <a:r>
-              <a:rPr lang="en-US" sz="3000" i="1" dirty="0">
+              <a:rPr lang="en-US" sz="3600" i="1" dirty="0">
                 <a:solidFill>
                   <a:srgbClr val="F0E7C8"/>
                 </a:solidFill>
@@ -5545,17 +5545,17 @@
               </a:rPr>
               <a:t>Tend bob.</a:t>
             </a:r>
-            <a:endParaRPr lang="en-US" sz="3000" dirty="0"/>
+            <a:endParaRPr lang="en-US" sz="3600" dirty="0"/>
           </a:p>
           <a:p>
             <a:pPr algn="ctr" indent="0" marL="0">
               <a:lnSpc>
-                <a:spcPct val="150000"/>
+                <a:spcPct val="145000"/>
               </a:lnSpc>
               <a:buNone/>
             </a:pPr>
             <a:r>
-              <a:rPr lang="en-US" sz="3000" i="1" dirty="0">
+              <a:rPr lang="en-US" sz="3600" i="1" dirty="0">
                 <a:solidFill>
                   <a:srgbClr val="F0E7C8"/>
                 </a:solidFill>
@@ -5565,17 +5565,17 @@
               </a:rPr>
               <a:t>Pay attention to bib.</a:t>
             </a:r>
-            <a:endParaRPr lang="en-US" sz="3000" dirty="0"/>
+            <a:endParaRPr lang="en-US" sz="3600" dirty="0"/>
           </a:p>
           <a:p>
             <a:pPr algn="ctr" indent="0" marL="0">
               <a:lnSpc>
-                <a:spcPct val="150000"/>
+                <a:spcPct val="145000"/>
               </a:lnSpc>
               <a:buNone/>
             </a:pPr>
             <a:r>
-              <a:rPr lang="en-US" sz="3000" i="1" dirty="0">
+              <a:rPr lang="en-US" sz="3600" i="1" dirty="0">
                 <a:solidFill>
                   <a:srgbClr val="F0E7C8"/>
                 </a:solidFill>
@@ -5585,17 +5585,17 @@
               </a:rPr>
               <a:t>Govern the L; let bab continue.</a:t>
             </a:r>
-            <a:endParaRPr lang="en-US" sz="3000" dirty="0"/>
+            <a:endParaRPr lang="en-US" sz="3600" dirty="0"/>
           </a:p>
           <a:p>
             <a:pPr algn="ctr" indent="0" marL="0">
               <a:lnSpc>
-                <a:spcPct val="150000"/>
+                <a:spcPct val="145000"/>
               </a:lnSpc>
               <a:buNone/>
             </a:pPr>
             <a:r>
-              <a:rPr lang="en-US" sz="3000" i="1" dirty="0">
+              <a:rPr lang="en-US" sz="3600" i="1" dirty="0">
                 <a:solidFill>
                   <a:srgbClr val="F0E7C8"/>
                 </a:solidFill>
@@ -5605,7 +5605,7 @@
               </a:rPr>
               <a:t>Hold boobs as tenet, not as exit.</a:t>
             </a:r>
-            <a:endParaRPr lang="en-US" sz="3000" dirty="0"/>
+            <a:endParaRPr lang="en-US" sz="3600" dirty="0"/>
           </a:p>
         </p:txBody>
       </p:sp>
@@ -5618,7 +5618,7 @@
         <p:spPr>
           <a:xfrm>
             <a:off x="0" y="5486400"/>
-            <a:ext cx="12191695" cy="457200"/>
+            <a:ext cx="12191695" cy="411480"/>
           </a:xfrm>
           <a:prstGeom prst="rect">
             <a:avLst/>
@@ -5634,7 +5634,7 @@
               <a:buNone/>
             </a:pPr>
             <a:r>
-              <a:rPr lang="en-US" sz="1700" i="1" dirty="0">
+              <a:rPr lang="en-US" sz="2000" i="1" dirty="0">
                 <a:solidFill>
                   <a:srgbClr val="F0E7C8"/>
                 </a:solidFill>
@@ -5644,7 +5644,7 @@
               </a:rPr>
               <a:t>Watch the dial. The four are held together.</a:t>
             </a:r>
-            <a:endParaRPr lang="en-US" sz="1700" dirty="0"/>
+            <a:endParaRPr lang="en-US" sz="2000" dirty="0"/>
           </a:p>
         </p:txBody>
       </p:sp>
@@ -5657,7 +5657,7 @@
         <p:spPr>
           <a:xfrm>
             <a:off x="0" y="5989320"/>
-            <a:ext cx="12191695" cy="457200"/>
+            <a:ext cx="12191695" cy="411480"/>
           </a:xfrm>
           <a:prstGeom prst="rect">
             <a:avLst/>
@@ -5673,7 +5673,7 @@
               <a:buNone/>
             </a:pPr>
             <a:r>
-              <a:rPr lang="en-US" sz="1800" i="1" dirty="0">
+              <a:rPr lang="en-US" sz="2200" i="1" dirty="0">
                 <a:solidFill>
                   <a:srgbClr val="FFD95C"/>
                 </a:solidFill>
@@ -5683,7 +5683,7 @@
               </a:rPr>
               <a:t>Bobble accordingly.</a:t>
             </a:r>
-            <a:endParaRPr lang="en-US" sz="1800" dirty="0"/>
+            <a:endParaRPr lang="en-US" sz="2200" dirty="0"/>
           </a:p>
         </p:txBody>
       </p:sp>
@@ -5744,7 +5744,7 @@
               <a:buNone/>
             </a:pPr>
             <a:r>
-              <a:rPr lang="en-US" sz="1600" i="1" dirty="0">
+              <a:rPr lang="en-US" sz="1800" i="1" dirty="0">
                 <a:solidFill>
                   <a:srgbClr val="D4A93A"/>
                 </a:solidFill>
@@ -5754,7 +5754,7 @@
               </a:rPr>
               <a:t>§ 0</a:t>
             </a:r>
-            <a:endParaRPr lang="en-US" sz="1600" dirty="0"/>
+            <a:endParaRPr lang="en-US" sz="1800" dirty="0"/>
           </a:p>
         </p:txBody>
       </p:sp>
@@ -5766,7 +5766,7 @@
         </p:nvSpPr>
         <p:spPr>
           <a:xfrm>
-            <a:off x="457200" y="2743200"/>
+            <a:off x="457200" y="2651760"/>
             <a:ext cx="11277295" cy="1371600"/>
           </a:xfrm>
           <a:prstGeom prst="rect">
@@ -5783,7 +5783,7 @@
               <a:buNone/>
             </a:pPr>
             <a:r>
-              <a:rPr lang="en-US" sz="5400" b="1" dirty="0">
+              <a:rPr lang="en-US" sz="5800" b="1" dirty="0">
                 <a:solidFill>
                   <a:srgbClr val="F0E7C8"/>
                 </a:solidFill>
@@ -5793,7 +5793,7 @@
               </a:rPr>
               <a:t>Why Four Boxes</a:t>
             </a:r>
-            <a:endParaRPr lang="en-US" sz="5400" dirty="0"/>
+            <a:endParaRPr lang="en-US" sz="5800" dirty="0"/>
           </a:p>
         </p:txBody>
       </p:sp>
@@ -5806,7 +5806,7 @@
         <p:spPr>
           <a:xfrm>
             <a:off x="914400" y="4206240"/>
-            <a:ext cx="10362895" cy="1005840"/>
+            <a:ext cx="10362895" cy="1188720"/>
           </a:xfrm>
           <a:prstGeom prst="rect">
             <a:avLst/>
@@ -5822,7 +5822,7 @@
               <a:buNone/>
             </a:pPr>
             <a:r>
-              <a:rPr lang="en-US" sz="2000" i="1" dirty="0">
+              <a:rPr lang="en-US" sz="2200" i="1" dirty="0">
                 <a:solidFill>
                   <a:srgbClr val="F0E7C8"/>
                 </a:solidFill>
@@ -5832,14 +5832,14 @@
               </a:rPr>
               <a:t>When something feels off, you don't always know what is off.</a:t>
             </a:r>
-            <a:endParaRPr lang="en-US" sz="2000" dirty="0"/>
+            <a:endParaRPr lang="en-US" sz="2200" dirty="0"/>
           </a:p>
           <a:p>
             <a:pPr algn="ctr" indent="0" marL="0">
               <a:buNone/>
             </a:pPr>
             <a:r>
-              <a:rPr lang="en-US" sz="2000" i="1" dirty="0">
+              <a:rPr lang="en-US" sz="2200" i="1" dirty="0">
                 <a:solidFill>
                   <a:srgbClr val="F0E7C8"/>
                 </a:solidFill>
@@ -5849,7 +5849,7 @@
               </a:rPr>
               <a:t>The 4B gives you four places to look.</a:t>
             </a:r>
-            <a:endParaRPr lang="en-US" sz="2000" dirty="0"/>
+            <a:endParaRPr lang="en-US" sz="2200" dirty="0"/>
           </a:p>
         </p:txBody>
       </p:sp>
@@ -5894,7 +5894,7 @@
         <p:spPr>
           <a:xfrm>
             <a:off x="548640" y="457200"/>
-            <a:ext cx="10972800" cy="320040"/>
+            <a:ext cx="10972800" cy="365760"/>
           </a:xfrm>
           <a:prstGeom prst="rect">
             <a:avLst/>
@@ -5910,7 +5910,7 @@
               <a:buNone/>
             </a:pPr>
             <a:r>
-              <a:rPr lang="en-US" sz="1100" b="1" spc="600" kern="0" dirty="0">
+              <a:rPr lang="en-US" sz="1200" b="1" spc="600" kern="0" dirty="0">
                 <a:solidFill>
                   <a:srgbClr val="D4A93A"/>
                 </a:solidFill>
@@ -5920,7 +5920,7 @@
               </a:rPr>
               <a:t>0  ·  WHY FOUR BOXES</a:t>
             </a:r>
-            <a:endParaRPr lang="en-US" sz="1100" dirty="0"/>
+            <a:endParaRPr lang="en-US" sz="1200" dirty="0"/>
           </a:p>
         </p:txBody>
       </p:sp>
@@ -5932,7 +5932,7 @@
         </p:nvSpPr>
         <p:spPr>
           <a:xfrm>
-            <a:off x="640080" y="868680"/>
+            <a:off x="640080" y="914400"/>
             <a:ext cx="10972800" cy="914400"/>
           </a:xfrm>
           <a:prstGeom prst="rect">
@@ -5949,7 +5949,7 @@
               <a:buNone/>
             </a:pPr>
             <a:r>
-              <a:rPr lang="en-US" sz="3600" b="1" dirty="0">
+              <a:rPr lang="en-US" sz="4000" b="1" dirty="0">
                 <a:solidFill>
                   <a:srgbClr val="0E1238"/>
                 </a:solidFill>
@@ -5959,7 +5959,7 @@
               </a:rPr>
               <a:t>Four boxes you can check any morning</a:t>
             </a:r>
-            <a:endParaRPr lang="en-US" sz="3600" dirty="0"/>
+            <a:endParaRPr lang="en-US" sz="4000" dirty="0"/>
           </a:p>
         </p:txBody>
       </p:sp>
@@ -5971,8 +5971,8 @@
         </p:nvSpPr>
         <p:spPr>
           <a:xfrm>
-            <a:off x="640080" y="2011680"/>
-            <a:ext cx="10972800" cy="4023360"/>
+            <a:off x="640080" y="2103120"/>
+            <a:ext cx="10972800" cy="4114800"/>
           </a:xfrm>
           <a:prstGeom prst="rect">
             <a:avLst/>
@@ -5995,7 +5995,7 @@
               <a:buChar char="●"/>
             </a:pPr>
             <a:r>
-              <a:rPr lang="en-US" sz="1600" dirty="0">
+              <a:rPr lang="en-US" sz="1800" dirty="0">
                 <a:solidFill>
                   <a:srgbClr val="0E1238"/>
                 </a:solidFill>
@@ -6005,7 +6005,7 @@
               </a:rPr>
               <a:t>Sometimes you wake up and something is off. You can't name what. The 4B framework gives you four boxes to open in order.</a:t>
             </a:r>
-            <a:endParaRPr lang="en-US" sz="1600" dirty="0"/>
+            <a:endParaRPr lang="en-US" sz="1800" dirty="0"/>
           </a:p>
           <a:p>
             <a:pPr marL="342900" indent="-342900">
@@ -6019,7 +6019,7 @@
               <a:buChar char="●"/>
             </a:pPr>
             <a:r>
-              <a:rPr lang="en-US" sz="1600" dirty="0">
+              <a:rPr lang="en-US" sz="1800" dirty="0">
                 <a:solidFill>
                   <a:srgbClr val="0E1238"/>
                 </a:solidFill>
@@ -6029,7 +6029,7 @@
               </a:rPr>
               <a:t>Bob — who you are underneath the changes.</a:t>
             </a:r>
-            <a:endParaRPr lang="en-US" sz="1600" dirty="0"/>
+            <a:endParaRPr lang="en-US" sz="1800" dirty="0"/>
           </a:p>
           <a:p>
             <a:pPr marL="342900" indent="-342900">
@@ -6043,7 +6043,7 @@
               <a:buChar char="●"/>
             </a:pPr>
             <a:r>
-              <a:rPr lang="en-US" sz="1600" dirty="0">
+              <a:rPr lang="en-US" sz="1800" dirty="0">
                 <a:solidFill>
                   <a:srgbClr val="0E1238"/>
                 </a:solidFill>
@@ -6051,9 +6051,9 @@
                 <a:ea typeface="Calibri" pitchFamily="34" charset="-122"/>
                 <a:cs typeface="Calibri" pitchFamily="34" charset="-120"/>
               </a:rPr>
-              <a:t>Bib — what feeds you (sleep, food, rest, people who give you energy back).</a:t>
-            </a:r>
-            <a:endParaRPr lang="en-US" sz="1600" dirty="0"/>
+              <a:t>Bib — what feeds you (sleep, food, rest, the people who give you energy back).</a:t>
+            </a:r>
+            <a:endParaRPr lang="en-US" sz="1800" dirty="0"/>
           </a:p>
           <a:p>
             <a:pPr marL="342900" indent="-342900">
@@ -6067,7 +6067,7 @@
               <a:buChar char="●"/>
             </a:pPr>
             <a:r>
-              <a:rPr lang="en-US" sz="1600" dirty="0">
+              <a:rPr lang="en-US" sz="1800" dirty="0">
                 <a:solidFill>
                   <a:srgbClr val="0E1238"/>
                 </a:solidFill>
@@ -6077,7 +6077,7 @@
               </a:rPr>
               <a:t>B(l)ab — who you talk to, and how much.</a:t>
             </a:r>
-            <a:endParaRPr lang="en-US" sz="1600" dirty="0"/>
+            <a:endParaRPr lang="en-US" sz="1800" dirty="0"/>
           </a:p>
           <a:p>
             <a:pPr marL="342900" indent="-342900">
@@ -6091,7 +6091,7 @@
               <a:buChar char="●"/>
             </a:pPr>
             <a:r>
-              <a:rPr lang="en-US" sz="1600" dirty="0">
+              <a:rPr lang="en-US" sz="1800" dirty="0">
                 <a:solidFill>
                   <a:srgbClr val="0E1238"/>
                 </a:solidFill>
@@ -6101,7 +6101,7 @@
               </a:rPr>
               <a:t>Boobs — what you enjoy, and whether you're enjoying it or escaping into it.</a:t>
             </a:r>
-            <a:endParaRPr lang="en-US" sz="1600" dirty="0"/>
+            <a:endParaRPr lang="en-US" sz="1800" dirty="0"/>
           </a:p>
           <a:p>
             <a:pPr marL="342900" indent="-342900">
@@ -6115,7 +6115,7 @@
               <a:buChar char="●"/>
             </a:pPr>
             <a:r>
-              <a:rPr lang="en-US" sz="1600" dirty="0">
+              <a:rPr lang="en-US" sz="1800" dirty="0">
                 <a:solidFill>
                   <a:srgbClr val="0E1238"/>
                 </a:solidFill>
@@ -6125,7 +6125,7 @@
               </a:rPr>
               <a:t>The names are silly on purpose. A framework you can't say out loud is one you won't use.</a:t>
             </a:r>
-            <a:endParaRPr lang="en-US" sz="1600" dirty="0"/>
+            <a:endParaRPr lang="en-US" sz="1800" dirty="0"/>
           </a:p>
         </p:txBody>
       </p:sp>
@@ -6154,7 +6154,7 @@
               <a:buNone/>
             </a:pPr>
             <a:r>
-              <a:rPr lang="en-US" sz="1000" i="1" dirty="0">
+              <a:rPr lang="en-US" sz="1100" i="1" dirty="0">
                 <a:solidFill>
                   <a:srgbClr val="8B8770"/>
                 </a:solidFill>
@@ -6164,7 +6164,7 @@
               </a:rPr>
               <a:t>Lecture 3  ·  intro</a:t>
             </a:r>
-            <a:endParaRPr lang="en-US" sz="1000" dirty="0"/>
+            <a:endParaRPr lang="en-US" sz="1100" dirty="0"/>
           </a:p>
         </p:txBody>
       </p:sp>
@@ -6225,7 +6225,7 @@
               <a:buNone/>
             </a:pPr>
             <a:r>
-              <a:rPr lang="en-US" sz="1600" i="1" dirty="0">
+              <a:rPr lang="en-US" sz="1800" i="1" dirty="0">
                 <a:solidFill>
                   <a:srgbClr val="D4A93A"/>
                 </a:solidFill>
@@ -6235,7 +6235,7 @@
               </a:rPr>
               <a:t>§ I</a:t>
             </a:r>
-            <a:endParaRPr lang="en-US" sz="1600" dirty="0"/>
+            <a:endParaRPr lang="en-US" sz="1800" dirty="0"/>
           </a:p>
         </p:txBody>
       </p:sp>
@@ -6247,8 +6247,8 @@
         </p:nvSpPr>
         <p:spPr>
           <a:xfrm>
-            <a:off x="457200" y="2743200"/>
-            <a:ext cx="11277295" cy="1371600"/>
+            <a:off x="457200" y="2468880"/>
+            <a:ext cx="11277295" cy="1645920"/>
           </a:xfrm>
           <a:prstGeom prst="rect">
             <a:avLst/>
@@ -6264,7 +6264,7 @@
               <a:buNone/>
             </a:pPr>
             <a:r>
-              <a:rPr lang="en-US" sz="9000" b="1" dirty="0">
+              <a:rPr lang="en-US" sz="10000" b="1" dirty="0">
                 <a:solidFill>
                   <a:srgbClr val="F0E7C8"/>
                 </a:solidFill>
@@ -6274,7 +6274,7 @@
               </a:rPr>
               <a:t>Bob</a:t>
             </a:r>
-            <a:endParaRPr lang="en-US" sz="9000" dirty="0"/>
+            <a:endParaRPr lang="en-US" sz="10000" dirty="0"/>
           </a:p>
         </p:txBody>
       </p:sp>
@@ -6286,8 +6286,8 @@
         </p:nvSpPr>
         <p:spPr>
           <a:xfrm>
-            <a:off x="914400" y="4389120"/>
-            <a:ext cx="10362895" cy="640080"/>
+            <a:off x="914400" y="4480560"/>
+            <a:ext cx="10362895" cy="731520"/>
           </a:xfrm>
           <a:prstGeom prst="rect">
             <a:avLst/>
@@ -6303,7 +6303,7 @@
               <a:buNone/>
             </a:pPr>
             <a:r>
-              <a:rPr lang="en-US" sz="2000" i="1" dirty="0">
+              <a:rPr lang="en-US" sz="2200" i="1" dirty="0">
                 <a:solidFill>
                   <a:srgbClr val="F0E7C8"/>
                 </a:solidFill>
@@ -6313,7 +6313,7 @@
               </a:rPr>
               <a:t>who you are underneath the changes</a:t>
             </a:r>
-            <a:endParaRPr lang="en-US" sz="2000" dirty="0"/>
+            <a:endParaRPr lang="en-US" sz="2200" dirty="0"/>
           </a:p>
         </p:txBody>
       </p:sp>
@@ -6358,7 +6358,7 @@
         <p:spPr>
           <a:xfrm>
             <a:off x="548640" y="457200"/>
-            <a:ext cx="10972800" cy="320040"/>
+            <a:ext cx="10972800" cy="365760"/>
           </a:xfrm>
           <a:prstGeom prst="rect">
             <a:avLst/>
@@ -6374,7 +6374,7 @@
               <a:buNone/>
             </a:pPr>
             <a:r>
-              <a:rPr lang="en-US" sz="1100" b="1" spc="600" kern="0" dirty="0">
+              <a:rPr lang="en-US" sz="1200" b="1" spc="600" kern="0" dirty="0">
                 <a:solidFill>
                   <a:srgbClr val="D4A93A"/>
                 </a:solidFill>
@@ -6384,7 +6384,7 @@
               </a:rPr>
               <a:t>I  ·  BOB</a:t>
             </a:r>
-            <a:endParaRPr lang="en-US" sz="1100" dirty="0"/>
+            <a:endParaRPr lang="en-US" sz="1200" dirty="0"/>
           </a:p>
         </p:txBody>
       </p:sp>
@@ -6396,7 +6396,7 @@
         </p:nvSpPr>
         <p:spPr>
           <a:xfrm>
-            <a:off x="640080" y="868680"/>
+            <a:off x="640080" y="914400"/>
             <a:ext cx="10972800" cy="914400"/>
           </a:xfrm>
           <a:prstGeom prst="rect">
@@ -6413,7 +6413,7 @@
               <a:buNone/>
             </a:pPr>
             <a:r>
-              <a:rPr lang="en-US" sz="3600" b="1" dirty="0">
+              <a:rPr lang="en-US" sz="4000" b="1" dirty="0">
                 <a:solidFill>
                   <a:srgbClr val="0E1238"/>
                 </a:solidFill>
@@ -6421,9 +6421,9 @@
                 <a:ea typeface="Georgia" pitchFamily="34" charset="-122"/>
                 <a:cs typeface="Georgia" pitchFamily="34" charset="-120"/>
               </a:rPr>
-              <a:t>Bob is the part of you that survives the changes</a:t>
-            </a:r>
-            <a:endParaRPr lang="en-US" sz="3600" dirty="0"/>
+              <a:t>Bob is what survives the changes</a:t>
+            </a:r>
+            <a:endParaRPr lang="en-US" sz="4000" dirty="0"/>
           </a:p>
         </p:txBody>
       </p:sp>
@@ -6435,8 +6435,8 @@
         </p:nvSpPr>
         <p:spPr>
           <a:xfrm>
-            <a:off x="640080" y="2011680"/>
-            <a:ext cx="10972800" cy="4023360"/>
+            <a:off x="640080" y="2103120"/>
+            <a:ext cx="10972800" cy="4114800"/>
           </a:xfrm>
           <a:prstGeom prst="rect">
             <a:avLst/>
@@ -6459,7 +6459,7 @@
               <a:buChar char="●"/>
             </a:pPr>
             <a:r>
-              <a:rPr lang="en-US" sz="1700" dirty="0">
+              <a:rPr lang="en-US" sz="2000" dirty="0">
                 <a:solidFill>
                   <a:srgbClr val="0E1238"/>
                 </a:solidFill>
@@ -6469,7 +6469,7 @@
               </a:rPr>
               <a:t>You will change your job, your city, your friends, your music, and your opinions many times in your life.</a:t>
             </a:r>
-            <a:endParaRPr lang="en-US" sz="1700" dirty="0"/>
+            <a:endParaRPr lang="en-US" sz="2000" dirty="0"/>
           </a:p>
           <a:p>
             <a:pPr marL="342900" indent="-342900">
@@ -6483,7 +6483,7 @@
               <a:buChar char="●"/>
             </a:pPr>
             <a:r>
-              <a:rPr lang="en-US" sz="1700" dirty="0">
+              <a:rPr lang="en-US" sz="2000" dirty="0">
                 <a:solidFill>
                   <a:srgbClr val="0E1238"/>
                 </a:solidFill>
@@ -6493,7 +6493,7 @@
               </a:rPr>
               <a:t>Bob is the part of you that is still recognizable as YOU after all those changes.</a:t>
             </a:r>
-            <a:endParaRPr lang="en-US" sz="1700" dirty="0"/>
+            <a:endParaRPr lang="en-US" sz="2000" dirty="0"/>
           </a:p>
           <a:p>
             <a:pPr marL="342900" indent="-342900">
@@ -6507,7 +6507,7 @@
               <a:buChar char="●"/>
             </a:pPr>
             <a:r>
-              <a:rPr lang="en-US" sz="1700" dirty="0">
+              <a:rPr lang="en-US" sz="2000" dirty="0">
                 <a:solidFill>
                   <a:srgbClr val="0E1238"/>
                 </a:solidFill>
@@ -6517,7 +6517,7 @@
               </a:rPr>
               <a:t>Bob is not your personality — that is your style.</a:t>
             </a:r>
-            <a:endParaRPr lang="en-US" sz="1700" dirty="0"/>
+            <a:endParaRPr lang="en-US" sz="2000" dirty="0"/>
           </a:p>
           <a:p>
             <a:pPr marL="342900" indent="-342900">
@@ -6531,7 +6531,7 @@
               <a:buChar char="●"/>
             </a:pPr>
             <a:r>
-              <a:rPr lang="en-US" sz="1700" dirty="0">
+              <a:rPr lang="en-US" sz="2000" dirty="0">
                 <a:solidFill>
                   <a:srgbClr val="0E1238"/>
                 </a:solidFill>
@@ -6541,7 +6541,7 @@
               </a:rPr>
               <a:t>Bob is not your beliefs — those are tools you pick up and put down.</a:t>
             </a:r>
-            <a:endParaRPr lang="en-US" sz="1700" dirty="0"/>
+            <a:endParaRPr lang="en-US" sz="2000" dirty="0"/>
           </a:p>
           <a:p>
             <a:pPr marL="342900" indent="-342900">
@@ -6555,7 +6555,7 @@
               <a:buChar char="●"/>
             </a:pPr>
             <a:r>
-              <a:rPr lang="en-US" sz="1700" dirty="0">
+              <a:rPr lang="en-US" sz="2000" dirty="0">
                 <a:solidFill>
                   <a:srgbClr val="0E1238"/>
                 </a:solidFill>
@@ -6565,7 +6565,7 @@
               </a:rPr>
               <a:t>Bob is the one picking the tools up. The driver, not the steering wheel.</a:t>
             </a:r>
-            <a:endParaRPr lang="en-US" sz="1700" dirty="0"/>
+            <a:endParaRPr lang="en-US" sz="2000" dirty="0"/>
           </a:p>
         </p:txBody>
       </p:sp>
@@ -6594,7 +6594,7 @@
               <a:buNone/>
             </a:pPr>
             <a:r>
-              <a:rPr lang="en-US" sz="1000" i="1" dirty="0">
+              <a:rPr lang="en-US" sz="1100" i="1" dirty="0">
                 <a:solidFill>
                   <a:srgbClr val="8B8770"/>
                 </a:solidFill>
@@ -6604,7 +6604,7 @@
               </a:rPr>
               <a:t>Lecture 3  ·  I</a:t>
             </a:r>
-            <a:endParaRPr lang="en-US" sz="1000" dirty="0"/>
+            <a:endParaRPr lang="en-US" sz="1100" dirty="0"/>
           </a:p>
         </p:txBody>
       </p:sp>
@@ -6649,7 +6649,7 @@
         <p:spPr>
           <a:xfrm>
             <a:off x="548640" y="457200"/>
-            <a:ext cx="10972800" cy="320040"/>
+            <a:ext cx="10972800" cy="365760"/>
           </a:xfrm>
           <a:prstGeom prst="rect">
             <a:avLst/>
@@ -6665,7 +6665,7 @@
               <a:buNone/>
             </a:pPr>
             <a:r>
-              <a:rPr lang="en-US" sz="1100" b="1" spc="600" kern="0" dirty="0">
+              <a:rPr lang="en-US" sz="1200" b="1" spc="600" kern="0" dirty="0">
                 <a:solidFill>
                   <a:srgbClr val="D4A93A"/>
                 </a:solidFill>
@@ -6675,7 +6675,7 @@
               </a:rPr>
               <a:t>I  ·  BOB</a:t>
             </a:r>
-            <a:endParaRPr lang="en-US" sz="1100" dirty="0"/>
+            <a:endParaRPr lang="en-US" sz="1200" dirty="0"/>
           </a:p>
         </p:txBody>
       </p:sp>
@@ -6687,7 +6687,7 @@
         </p:nvSpPr>
         <p:spPr>
           <a:xfrm>
-            <a:off x="640080" y="868680"/>
+            <a:off x="640080" y="914400"/>
             <a:ext cx="10972800" cy="914400"/>
           </a:xfrm>
           <a:prstGeom prst="rect">
@@ -6704,7 +6704,7 @@
               <a:buNone/>
             </a:pPr>
             <a:r>
-              <a:rPr lang="en-US" sz="3600" b="1" dirty="0">
+              <a:rPr lang="en-US" sz="4000" b="1" dirty="0">
                 <a:solidFill>
                   <a:srgbClr val="0E1238"/>
                 </a:solidFill>
@@ -6712,9 +6712,9 @@
                 <a:ea typeface="Georgia" pitchFamily="34" charset="-122"/>
                 <a:cs typeface="Georgia" pitchFamily="34" charset="-120"/>
               </a:rPr>
-              <a:t>A picture: the phone call ten years out</a:t>
-            </a:r>
-            <a:endParaRPr lang="en-US" sz="3600" dirty="0"/>
+              <a:t>The phone call, ten years out</a:t>
+            </a:r>
+            <a:endParaRPr lang="en-US" sz="4000" dirty="0"/>
           </a:p>
         </p:txBody>
       </p:sp>
@@ -6726,8 +6726,8 @@
         </p:nvSpPr>
         <p:spPr>
           <a:xfrm>
-            <a:off x="640080" y="1920240"/>
-            <a:ext cx="10972800" cy="1188720"/>
+            <a:off x="640080" y="2011680"/>
+            <a:ext cx="10972800" cy="822960"/>
           </a:xfrm>
           <a:prstGeom prst="rect">
             <a:avLst/>
@@ -6743,7 +6743,7 @@
               <a:buNone/>
             </a:pPr>
             <a:r>
-              <a:rPr lang="en-US" sz="1700" dirty="0">
+              <a:rPr lang="en-US" sz="1900" dirty="0">
                 <a:solidFill>
                   <a:srgbClr val="0E1238"/>
                 </a:solidFill>
@@ -6753,7 +6753,7 @@
               </a:rPr>
               <a:t>Picture yourself ten years from now. Different job. Maybe a different city. A different haircut. You pick up the phone and call your closest friend from today.</a:t>
             </a:r>
-            <a:endParaRPr lang="en-US" sz="1700" dirty="0"/>
+            <a:endParaRPr lang="en-US" sz="1900" dirty="0"/>
           </a:p>
         </p:txBody>
       </p:sp>
@@ -6765,8 +6765,8 @@
         </p:nvSpPr>
         <p:spPr>
           <a:xfrm>
-            <a:off x="640080" y="3108960"/>
-            <a:ext cx="10972800" cy="1188720"/>
+            <a:off x="640080" y="2971800"/>
+            <a:ext cx="10972800" cy="822960"/>
           </a:xfrm>
           <a:prstGeom prst="rect">
             <a:avLst/>
@@ -6782,7 +6782,7 @@
               <a:buNone/>
             </a:pPr>
             <a:r>
-              <a:rPr lang="en-US" sz="1700" b="1" dirty="0">
+              <a:rPr lang="en-US" sz="1900" b="1" dirty="0">
                 <a:solidFill>
                   <a:srgbClr val="0E1238"/>
                 </a:solidFill>
@@ -6796,7 +6796,7 @@
               <a:buNone/>
             </a:pPr>
             <a:r>
-              <a:rPr lang="en-US" sz="1700" dirty="0">
+              <a:rPr lang="en-US" sz="1900" dirty="0">
                 <a:solidFill>
                   <a:srgbClr val="0E1238"/>
                 </a:solidFill>
@@ -6806,7 +6806,7 @@
               </a:rPr>
               <a:t>Not your hair. Not your job. The way you greet them. The kind of jokes you make. The way you ask about their parents.</a:t>
             </a:r>
-            <a:endParaRPr lang="en-US" sz="1700" dirty="0"/>
+            <a:endParaRPr lang="en-US" sz="1900" dirty="0"/>
           </a:p>
         </p:txBody>
       </p:sp>
@@ -6818,8 +6818,8 @@
         </p:nvSpPr>
         <p:spPr>
           <a:xfrm>
-            <a:off x="640080" y="4297680"/>
-            <a:ext cx="10972800" cy="1188720"/>
+            <a:off x="640080" y="3931920"/>
+            <a:ext cx="10972800" cy="822960"/>
           </a:xfrm>
           <a:prstGeom prst="rect">
             <a:avLst/>
@@ -6835,7 +6835,7 @@
               <a:buNone/>
             </a:pPr>
             <a:r>
-              <a:rPr lang="en-US" sz="1700" i="1" dirty="0">
+              <a:rPr lang="en-US" sz="1900" i="1" dirty="0">
                 <a:solidFill>
                   <a:srgbClr val="0E1238"/>
                 </a:solidFill>
@@ -6849,7 +6849,7 @@
               <a:buNone/>
             </a:pPr>
             <a:r>
-              <a:rPr lang="en-US" sz="1700" dirty="0">
+              <a:rPr lang="en-US" sz="1900" dirty="0">
                 <a:solidFill>
                   <a:srgbClr val="0E1238"/>
                 </a:solidFill>
@@ -6859,7 +6859,7 @@
               </a:rPr>
               <a:t>If your friend would say "you sound like a stranger," Bob has drifted. The work of Bob is making sure that future call still sounds like you.</a:t>
             </a:r>
-            <a:endParaRPr lang="en-US" sz="1700" dirty="0"/>
+            <a:endParaRPr lang="en-US" sz="1900" dirty="0"/>
           </a:p>
         </p:txBody>
       </p:sp>
@@ -6871,8 +6871,8 @@
         </p:nvSpPr>
         <p:spPr>
           <a:xfrm>
-            <a:off x="1371600" y="5120640"/>
-            <a:ext cx="9418320" cy="914400"/>
+            <a:off x="1371600" y="5212080"/>
+            <a:ext cx="9418320" cy="777240"/>
           </a:xfrm>
           <a:prstGeom prst="rect">
             <a:avLst/>
@@ -6890,7 +6890,7 @@
               <a:buNone/>
             </a:pPr>
             <a:r>
-              <a:rPr lang="en-US" sz="1700" i="1" dirty="0">
+              <a:rPr lang="en-US" sz="2000" i="1" dirty="0">
                 <a:solidFill>
                   <a:srgbClr val="0E1238"/>
                 </a:solidFill>
@@ -6900,7 +6900,7 @@
               </a:rPr>
               <a:t>"Without bob you ain't."</a:t>
             </a:r>
-            <a:endParaRPr lang="en-US" sz="1700" dirty="0"/>
+            <a:endParaRPr lang="en-US" sz="2000" dirty="0"/>
           </a:p>
         </p:txBody>
       </p:sp>
@@ -6929,7 +6929,7 @@
               <a:buNone/>
             </a:pPr>
             <a:r>
-              <a:rPr lang="en-US" sz="1000" i="1" dirty="0">
+              <a:rPr lang="en-US" sz="1100" i="1" dirty="0">
                 <a:solidFill>
                   <a:srgbClr val="8B8770"/>
                 </a:solidFill>
@@ -6939,7 +6939,7 @@
               </a:rPr>
               <a:t>Lecture 3  ·  I</a:t>
             </a:r>
-            <a:endParaRPr lang="en-US" sz="1000" dirty="0"/>
+            <a:endParaRPr lang="en-US" sz="1100" dirty="0"/>
           </a:p>
         </p:txBody>
       </p:sp>
@@ -7000,7 +7000,7 @@
               <a:buNone/>
             </a:pPr>
             <a:r>
-              <a:rPr lang="en-US" sz="1600" i="1" dirty="0">
+              <a:rPr lang="en-US" sz="1800" i="1" dirty="0">
                 <a:solidFill>
                   <a:srgbClr val="D4A93A"/>
                 </a:solidFill>
@@ -7010,7 +7010,7 @@
               </a:rPr>
               <a:t>§ II</a:t>
             </a:r>
-            <a:endParaRPr lang="en-US" sz="1600" dirty="0"/>
+            <a:endParaRPr lang="en-US" sz="1800" dirty="0"/>
           </a:p>
         </p:txBody>
       </p:sp>
@@ -7022,8 +7022,8 @@
         </p:nvSpPr>
         <p:spPr>
           <a:xfrm>
-            <a:off x="457200" y="2743200"/>
-            <a:ext cx="11277295" cy="1371600"/>
+            <a:off x="457200" y="2468880"/>
+            <a:ext cx="11277295" cy="1645920"/>
           </a:xfrm>
           <a:prstGeom prst="rect">
             <a:avLst/>
@@ -7039,7 +7039,7 @@
               <a:buNone/>
             </a:pPr>
             <a:r>
-              <a:rPr lang="en-US" sz="9000" b="1" dirty="0">
+              <a:rPr lang="en-US" sz="10000" b="1" dirty="0">
                 <a:solidFill>
                   <a:srgbClr val="F0E7C8"/>
                 </a:solidFill>
@@ -7049,7 +7049,7 @@
               </a:rPr>
               <a:t>Bib</a:t>
             </a:r>
-            <a:endParaRPr lang="en-US" sz="9000" dirty="0"/>
+            <a:endParaRPr lang="en-US" sz="10000" dirty="0"/>
           </a:p>
         </p:txBody>
       </p:sp>
@@ -7061,8 +7061,8 @@
         </p:nvSpPr>
         <p:spPr>
           <a:xfrm>
-            <a:off x="914400" y="4389120"/>
-            <a:ext cx="10362895" cy="640080"/>
+            <a:off x="914400" y="4480560"/>
+            <a:ext cx="10362895" cy="731520"/>
           </a:xfrm>
           <a:prstGeom prst="rect">
             <a:avLst/>
@@ -7078,7 +7078,7 @@
               <a:buNone/>
             </a:pPr>
             <a:r>
-              <a:rPr lang="en-US" sz="2000" i="1" dirty="0">
+              <a:rPr lang="en-US" sz="2200" i="1" dirty="0">
                 <a:solidFill>
                   <a:srgbClr val="F0E7C8"/>
                 </a:solidFill>
@@ -7088,7 +7088,7 @@
               </a:rPr>
               <a:t>what feeds you (and what you ignore)</a:t>
             </a:r>
-            <a:endParaRPr lang="en-US" sz="2000" dirty="0"/>
+            <a:endParaRPr lang="en-US" sz="2200" dirty="0"/>
           </a:p>
         </p:txBody>
       </p:sp>
@@ -7133,7 +7133,7 @@
         <p:spPr>
           <a:xfrm>
             <a:off x="548640" y="457200"/>
-            <a:ext cx="10972800" cy="320040"/>
+            <a:ext cx="10972800" cy="365760"/>
           </a:xfrm>
           <a:prstGeom prst="rect">
             <a:avLst/>
@@ -7149,7 +7149,7 @@
               <a:buNone/>
             </a:pPr>
             <a:r>
-              <a:rPr lang="en-US" sz="1100" b="1" spc="600" kern="0" dirty="0">
+              <a:rPr lang="en-US" sz="1200" b="1" spc="600" kern="0" dirty="0">
                 <a:solidFill>
                   <a:srgbClr val="D4A93A"/>
                 </a:solidFill>
@@ -7159,7 +7159,7 @@
               </a:rPr>
               <a:t>II  ·  BIB</a:t>
             </a:r>
-            <a:endParaRPr lang="en-US" sz="1100" dirty="0"/>
+            <a:endParaRPr lang="en-US" sz="1200" dirty="0"/>
           </a:p>
         </p:txBody>
       </p:sp>
@@ -7171,7 +7171,7 @@
         </p:nvSpPr>
         <p:spPr>
           <a:xfrm>
-            <a:off x="640080" y="868680"/>
+            <a:off x="640080" y="914400"/>
             <a:ext cx="10972800" cy="914400"/>
           </a:xfrm>
           <a:prstGeom prst="rect">
@@ -7188,7 +7188,7 @@
               <a:buNone/>
             </a:pPr>
             <a:r>
-              <a:rPr lang="en-US" sz="3600" b="1" dirty="0">
+              <a:rPr lang="en-US" sz="4000" b="1" dirty="0">
                 <a:solidFill>
                   <a:srgbClr val="0E1238"/>
                 </a:solidFill>
@@ -7198,7 +7198,7 @@
               </a:rPr>
               <a:t>We are smart, but not at eating</a:t>
             </a:r>
-            <a:endParaRPr lang="en-US" sz="3600" dirty="0"/>
+            <a:endParaRPr lang="en-US" sz="4000" dirty="0"/>
           </a:p>
         </p:txBody>
       </p:sp>
@@ -7210,8 +7210,8 @@
         </p:nvSpPr>
         <p:spPr>
           <a:xfrm>
-            <a:off x="640080" y="2011680"/>
-            <a:ext cx="10972800" cy="4023360"/>
+            <a:off x="640080" y="2103120"/>
+            <a:ext cx="10972800" cy="4114800"/>
           </a:xfrm>
           <a:prstGeom prst="rect">
             <a:avLst/>
@@ -7234,7 +7234,7 @@
               <a:buChar char="●"/>
             </a:pPr>
             <a:r>
-              <a:rPr lang="en-US" sz="1700" dirty="0">
+              <a:rPr lang="en-US" sz="2000" dirty="0">
                 <a:solidFill>
                   <a:srgbClr val="0E1238"/>
                 </a:solidFill>
@@ -7242,9 +7242,9 @@
                 <a:ea typeface="Calibri" pitchFamily="34" charset="-122"/>
                 <a:cs typeface="Calibri" pitchFamily="34" charset="-120"/>
               </a:rPr>
-              <a:t>Bib is the box that holds the things that keep you running: sleep, food, water, rest, and the people who give you energy back.</a:t>
-            </a:r>
-            <a:endParaRPr lang="en-US" sz="1700" dirty="0"/>
+              <a:t>Bib is the box that holds what keeps you running: sleep, food, water, rest, and the people who give you energy back.</a:t>
+            </a:r>
+            <a:endParaRPr lang="en-US" sz="2000" dirty="0"/>
           </a:p>
           <a:p>
             <a:pPr marL="342900" indent="-342900">
@@ -7258,7 +7258,7 @@
               <a:buChar char="●"/>
             </a:pPr>
             <a:r>
-              <a:rPr lang="en-US" sz="1700" dirty="0">
+              <a:rPr lang="en-US" sz="2000" dirty="0">
                 <a:solidFill>
                   <a:srgbClr val="0E1238"/>
                 </a:solidFill>
@@ -7266,9 +7266,9 @@
                 <a:ea typeface="Calibri" pitchFamily="34" charset="-122"/>
                 <a:cs typeface="Calibri" pitchFamily="34" charset="-120"/>
               </a:rPr>
-              <a:t>The warning: your brain can outvote your body. Your brain can say "I'll finish this episode first" when your body has been asking to sleep for two hours.</a:t>
-            </a:r>
-            <a:endParaRPr lang="en-US" sz="1700" dirty="0"/>
+              <a:t>The warning: your brain can outvote your body. Your brain will say "I'll finish this episode first" when your body has been asking to sleep for two hours.</a:t>
+            </a:r>
+            <a:endParaRPr lang="en-US" sz="2000" dirty="0"/>
           </a:p>
           <a:p>
             <a:pPr marL="342900" indent="-342900">
@@ -7282,7 +7282,7 @@
               <a:buChar char="●"/>
             </a:pPr>
             <a:r>
-              <a:rPr lang="en-US" sz="1700" dirty="0">
+              <a:rPr lang="en-US" sz="2000" dirty="0">
                 <a:solidFill>
                   <a:srgbClr val="0E1238"/>
                 </a:solidFill>
@@ -7292,7 +7292,7 @@
               </a:rPr>
               <a:t>"I'm not hungry, just bored." "One more coffee." "I can pull an all-nighter." Three small lies your brain tells when bib is being ignored.</a:t>
             </a:r>
-            <a:endParaRPr lang="en-US" sz="1700" dirty="0"/>
+            <a:endParaRPr lang="en-US" sz="2000" dirty="0"/>
           </a:p>
           <a:p>
             <a:pPr marL="342900" indent="-342900">
@@ -7306,7 +7306,7 @@
               <a:buChar char="●"/>
             </a:pPr>
             <a:r>
-              <a:rPr lang="en-US" sz="1700" dirty="0">
+              <a:rPr lang="en-US" sz="2000" dirty="0">
                 <a:solidFill>
                   <a:srgbClr val="0E1238"/>
                 </a:solidFill>
@@ -7316,7 +7316,7 @@
               </a:rPr>
               <a:t>The body is quiet. The brain is loud. Bib is the practice of listening to the quiet one.</a:t>
             </a:r>
-            <a:endParaRPr lang="en-US" sz="1700" dirty="0"/>
+            <a:endParaRPr lang="en-US" sz="2000" dirty="0"/>
           </a:p>
         </p:txBody>
       </p:sp>
@@ -7345,7 +7345,7 @@
               <a:buNone/>
             </a:pPr>
             <a:r>
-              <a:rPr lang="en-US" sz="1000" i="1" dirty="0">
+              <a:rPr lang="en-US" sz="1100" i="1" dirty="0">
                 <a:solidFill>
                   <a:srgbClr val="8B8770"/>
                 </a:solidFill>
@@ -7355,7 +7355,7 @@
               </a:rPr>
               <a:t>Lecture 3  ·  II</a:t>
             </a:r>
-            <a:endParaRPr lang="en-US" sz="1000" dirty="0"/>
+            <a:endParaRPr lang="en-US" sz="1100" dirty="0"/>
           </a:p>
         </p:txBody>
       </p:sp>
@@ -7400,7 +7400,7 @@
         <p:spPr>
           <a:xfrm>
             <a:off x="548640" y="457200"/>
-            <a:ext cx="10972800" cy="320040"/>
+            <a:ext cx="10972800" cy="365760"/>
           </a:xfrm>
           <a:prstGeom prst="rect">
             <a:avLst/>
@@ -7416,7 +7416,7 @@
               <a:buNone/>
             </a:pPr>
             <a:r>
-              <a:rPr lang="en-US" sz="1100" b="1" spc="600" kern="0" dirty="0">
+              <a:rPr lang="en-US" sz="1200" b="1" spc="600" kern="0" dirty="0">
                 <a:solidFill>
                   <a:srgbClr val="D4A93A"/>
                 </a:solidFill>
@@ -7426,7 +7426,7 @@
               </a:rPr>
               <a:t>II  ·  BIB</a:t>
             </a:r>
-            <a:endParaRPr lang="en-US" sz="1100" dirty="0"/>
+            <a:endParaRPr lang="en-US" sz="1200" dirty="0"/>
           </a:p>
         </p:txBody>
       </p:sp>
@@ -7438,7 +7438,7 @@
         </p:nvSpPr>
         <p:spPr>
           <a:xfrm>
-            <a:off x="640080" y="868680"/>
+            <a:off x="640080" y="914400"/>
             <a:ext cx="10972800" cy="914400"/>
           </a:xfrm>
           <a:prstGeom prst="rect">
@@ -7455,7 +7455,7 @@
               <a:buNone/>
             </a:pPr>
             <a:r>
-              <a:rPr lang="en-US" sz="3600" b="1" dirty="0">
+              <a:rPr lang="en-US" sz="4000" b="1" dirty="0">
                 <a:solidFill>
                   <a:srgbClr val="0E1238"/>
                 </a:solidFill>
@@ -7465,7 +7465,7 @@
               </a:rPr>
               <a:t>What attending to bib looks like</a:t>
             </a:r>
-            <a:endParaRPr lang="en-US" sz="3600" dirty="0"/>
+            <a:endParaRPr lang="en-US" sz="4000" dirty="0"/>
           </a:p>
         </p:txBody>
       </p:sp>
@@ -7477,8 +7477,8 @@
         </p:nvSpPr>
         <p:spPr>
           <a:xfrm>
-            <a:off x="640080" y="2011680"/>
-            <a:ext cx="10972800" cy="4023360"/>
+            <a:off x="640080" y="2103120"/>
+            <a:ext cx="10972800" cy="3017520"/>
           </a:xfrm>
           <a:prstGeom prst="rect">
             <a:avLst/>
@@ -7501,7 +7501,7 @@
               <a:buChar char="●"/>
             </a:pPr>
             <a:r>
-              <a:rPr lang="en-US" sz="1700" dirty="0">
+              <a:rPr lang="en-US" sz="2000" dirty="0">
                 <a:solidFill>
                   <a:srgbClr val="0E1238"/>
                 </a:solidFill>
@@ -7511,7 +7511,7 @@
               </a:rPr>
               <a:t>You notice you are snapping at your roommate. You haven't slept more than five hours in three days. The snapping is bib, not your roommate.</a:t>
             </a:r>
-            <a:endParaRPr lang="en-US" sz="1700" dirty="0"/>
+            <a:endParaRPr lang="en-US" sz="2000" dirty="0"/>
           </a:p>
           <a:p>
             <a:pPr marL="342900" indent="-342900">
@@ -7525,7 +7525,7 @@
               <a:buChar char="●"/>
             </a:pPr>
             <a:r>
-              <a:rPr lang="en-US" sz="1700" dirty="0">
+              <a:rPr lang="en-US" sz="2000" dirty="0">
                 <a:solidFill>
                   <a:srgbClr val="0E1238"/>
                 </a:solidFill>
@@ -7535,7 +7535,7 @@
               </a:rPr>
               <a:t>You feel a headache at 3 p.m. and realize you haven't drunk water since breakfast.</a:t>
             </a:r>
-            <a:endParaRPr lang="en-US" sz="1700" dirty="0"/>
+            <a:endParaRPr lang="en-US" sz="2000" dirty="0"/>
           </a:p>
           <a:p>
             <a:pPr marL="342900" indent="-342900">
@@ -7549,7 +7549,7 @@
               <a:buChar char="●"/>
             </a:pPr>
             <a:r>
-              <a:rPr lang="en-US" sz="1700" dirty="0">
+              <a:rPr lang="en-US" sz="2000" dirty="0">
                 <a:solidFill>
                   <a:srgbClr val="0E1238"/>
                 </a:solidFill>
@@ -7559,7 +7559,7 @@
               </a:rPr>
               <a:t>You feel drained after texting one friend, lit up after texting another. That is bib information.</a:t>
             </a:r>
-            <a:endParaRPr lang="en-US" sz="1700" dirty="0"/>
+            <a:endParaRPr lang="en-US" sz="2000" dirty="0"/>
           </a:p>
           <a:p>
             <a:pPr marL="342900" indent="-342900">
@@ -7573,7 +7573,7 @@
               <a:buChar char="●"/>
             </a:pPr>
             <a:r>
-              <a:rPr lang="en-US" sz="1700" dirty="0">
+              <a:rPr lang="en-US" sz="2000" dirty="0">
                 <a:solidFill>
                   <a:srgbClr val="0E1238"/>
                 </a:solidFill>
@@ -7581,9 +7581,9 @@
                 <a:ea typeface="Calibri" pitchFamily="34" charset="-122"/>
                 <a:cs typeface="Calibri" pitchFamily="34" charset="-120"/>
               </a:rPr>
-              <a:t>Bib doesn't ask you to be perfect at any of this. It asks you to notice when you've drifted — and to come back.</a:t>
-            </a:r>
-            <a:endParaRPr lang="en-US" sz="1700" dirty="0"/>
+              <a:t>Bib doesn't ask you to be perfect. It asks you to notice when you've drifted — and to come back.</a:t>
+            </a:r>
+            <a:endParaRPr lang="en-US" sz="2000" dirty="0"/>
           </a:p>
         </p:txBody>
       </p:sp>
@@ -7595,8 +7595,8 @@
         </p:nvSpPr>
         <p:spPr>
           <a:xfrm>
-            <a:off x="1371600" y="5120640"/>
-            <a:ext cx="9418320" cy="914400"/>
+            <a:off x="1371600" y="5303520"/>
+            <a:ext cx="9418320" cy="777240"/>
           </a:xfrm>
           <a:prstGeom prst="rect">
             <a:avLst/>
@@ -7614,7 +7614,7 @@
               <a:buNone/>
             </a:pPr>
             <a:r>
-              <a:rPr lang="en-US" sz="1700" i="1" dirty="0">
+              <a:rPr lang="en-US" sz="2000" i="1" dirty="0">
                 <a:solidFill>
                   <a:srgbClr val="0E1238"/>
                 </a:solidFill>
@@ -7624,7 +7624,7 @@
               </a:rPr>
               <a:t>"The drift is the default. The coming-back is the practice."</a:t>
             </a:r>
-            <a:endParaRPr lang="en-US" sz="1700" dirty="0"/>
+            <a:endParaRPr lang="en-US" sz="2000" dirty="0"/>
           </a:p>
         </p:txBody>
       </p:sp>
@@ -7653,7 +7653,7 @@
               <a:buNone/>
             </a:pPr>
             <a:r>
-              <a:rPr lang="en-US" sz="1000" i="1" dirty="0">
+              <a:rPr lang="en-US" sz="1100" i="1" dirty="0">
                 <a:solidFill>
                   <a:srgbClr val="8B8770"/>
                 </a:solidFill>
@@ -7663,7 +7663,7 @@
               </a:rPr>
               <a:t>Lecture 3  ·  II</a:t>
             </a:r>
-            <a:endParaRPr lang="en-US" sz="1000" dirty="0"/>
+            <a:endParaRPr lang="en-US" sz="1100" dirty="0"/>
           </a:p>
         </p:txBody>
       </p:sp>

</xml_diff>